<commit_message>
Add final submission report, embedded live screenshots, updated presentation, and live links
</commit_message>
<xml_diff>
--- a/docs/Group2_COVID19_Presentation.pptx
+++ b/docs/Group2_COVID19_Presentation.pptx
@@ -5,12 +5,13 @@
     <p:sldMasterId id="2147483648" r:id="rId1"/>
   </p:sldMasterIdLst>
   <p:sldIdLst>
-    <p:sldId id="256" r:id="rId2"/>
-    <p:sldId id="257" r:id="rId3"/>
-    <p:sldId id="258" r:id="rId4"/>
-    <p:sldId id="259" r:id="rId5"/>
+    <p:sldId id="256" r:id="rId7"/>
+    <p:sldId id="257" r:id="rId8"/>
+    <p:sldId id="258" r:id="rId9"/>
+    <p:sldId id="259" r:id="rId10"/>
+    <p:sldId id="260" r:id="rId11"/>
   </p:sldIdLst>
-  <p:sldSz cx="12192000" cy="6858000"/>
+  <p:sldSz cx="12191695" cy="6858000" type="screen4x3"/>
   <p:notesSz cx="6858000" cy="9144000"/>
   <p:defaultTextStyle>
     <a:defPPr>
@@ -107,91 +108,7 @@
       </a:defRPr>
     </a:lvl9pPr>
   </p:defaultTextStyle>
-  <p:extLst>
-    <p:ext uri="{EFAFB233-063F-42B5-8137-9DF3F51BA10A}">
-      <p15:sldGuideLst xmlns:p15="http://schemas.microsoft.com/office/powerpoint/2012/main">
-        <p15:guide id="1" orient="horz" pos="2160">
-          <p15:clr>
-            <a:srgbClr val="A4A3A4"/>
-          </p15:clr>
-        </p15:guide>
-        <p15:guide id="2" pos="2880">
-          <p15:clr>
-            <a:srgbClr val="A4A3A4"/>
-          </p15:clr>
-        </p15:guide>
-      </p15:sldGuideLst>
-    </p:ext>
-  </p:extLst>
 </p:presentation>
-</file>
-
-<file path=ppt/changesInfos/changesInfo1.xml><?xml version="1.0" encoding="utf-8"?>
-<pc:chgInfo xmlns:a="http://schemas.openxmlformats.org/drawingml/2006/main" xmlns:r="http://schemas.openxmlformats.org/officeDocument/2006/relationships" xmlns:ac="http://schemas.microsoft.com/office/drawing/2013/main/command" xmlns:pc="http://schemas.microsoft.com/office/powerpoint/2013/main/command">
-  <pc:docChgLst>
-    <pc:chgData name="NISHANT GIRI" userId="fd601e8d16fbe851" providerId="LiveId" clId="{3EE9B37B-2CCC-4382-87C5-8848E438C463}"/>
-    <pc:docChg chg="modSld">
-      <pc:chgData name="NISHANT GIRI" userId="fd601e8d16fbe851" providerId="LiveId" clId="{3EE9B37B-2CCC-4382-87C5-8848E438C463}" dt="2026-10-14T07:21:17.921" v="7" actId="1076"/>
-      <pc:docMkLst>
-        <pc:docMk/>
-      </pc:docMkLst>
-      <pc:sldChg chg="modSp mod">
-        <pc:chgData name="NISHANT GIRI" userId="fd601e8d16fbe851" providerId="LiveId" clId="{3EE9B37B-2CCC-4382-87C5-8848E438C463}" dt="2026-10-14T07:20:43.020" v="3" actId="113"/>
-        <pc:sldMkLst>
-          <pc:docMk/>
-          <pc:sldMk cId="0" sldId="257"/>
-        </pc:sldMkLst>
-        <pc:spChg chg="mod">
-          <ac:chgData name="NISHANT GIRI" userId="fd601e8d16fbe851" providerId="LiveId" clId="{3EE9B37B-2CCC-4382-87C5-8848E438C463}" dt="2026-10-14T07:20:43.020" v="3" actId="113"/>
-          <ac:spMkLst>
-            <pc:docMk/>
-            <pc:sldMk cId="0" sldId="257"/>
-            <ac:spMk id="4" creationId="{00000000-0000-0000-0000-000000000000}"/>
-          </ac:spMkLst>
-        </pc:spChg>
-        <pc:spChg chg="mod">
-          <ac:chgData name="NISHANT GIRI" userId="fd601e8d16fbe851" providerId="LiveId" clId="{3EE9B37B-2CCC-4382-87C5-8848E438C463}" dt="2026-10-14T07:20:36.115" v="2" actId="255"/>
-          <ac:spMkLst>
-            <pc:docMk/>
-            <pc:sldMk cId="0" sldId="257"/>
-            <ac:spMk id="6" creationId="{00000000-0000-0000-0000-000000000000}"/>
-          </ac:spMkLst>
-        </pc:spChg>
-      </pc:sldChg>
-      <pc:sldChg chg="modSp mod">
-        <pc:chgData name="NISHANT GIRI" userId="fd601e8d16fbe851" providerId="LiveId" clId="{3EE9B37B-2CCC-4382-87C5-8848E438C463}" dt="2026-10-14T07:21:17.921" v="7" actId="1076"/>
-        <pc:sldMkLst>
-          <pc:docMk/>
-          <pc:sldMk cId="0" sldId="258"/>
-        </pc:sldMkLst>
-        <pc:spChg chg="mod">
-          <ac:chgData name="NISHANT GIRI" userId="fd601e8d16fbe851" providerId="LiveId" clId="{3EE9B37B-2CCC-4382-87C5-8848E438C463}" dt="2026-10-14T07:21:09.006" v="6" actId="1076"/>
-          <ac:spMkLst>
-            <pc:docMk/>
-            <pc:sldMk cId="0" sldId="258"/>
-            <ac:spMk id="5" creationId="{00000000-0000-0000-0000-000000000000}"/>
-          </ac:spMkLst>
-        </pc:spChg>
-        <pc:spChg chg="mod">
-          <ac:chgData name="NISHANT GIRI" userId="fd601e8d16fbe851" providerId="LiveId" clId="{3EE9B37B-2CCC-4382-87C5-8848E438C463}" dt="2026-10-14T07:20:58.426" v="5" actId="255"/>
-          <ac:spMkLst>
-            <pc:docMk/>
-            <pc:sldMk cId="0" sldId="258"/>
-            <ac:spMk id="6" creationId="{00000000-0000-0000-0000-000000000000}"/>
-          </ac:spMkLst>
-        </pc:spChg>
-        <pc:spChg chg="mod">
-          <ac:chgData name="NISHANT GIRI" userId="fd601e8d16fbe851" providerId="LiveId" clId="{3EE9B37B-2CCC-4382-87C5-8848E438C463}" dt="2026-10-14T07:21:17.921" v="7" actId="1076"/>
-          <ac:spMkLst>
-            <pc:docMk/>
-            <pc:sldMk cId="0" sldId="258"/>
-            <ac:spMk id="7" creationId="{00000000-0000-0000-0000-000000000000}"/>
-          </ac:spMkLst>
-        </pc:spChg>
-      </pc:sldChg>
-    </pc:docChg>
-  </pc:docChgLst>
-</pc:chgInfo>
 </file>
 
 <file path=ppt/slideLayouts/slideLayout1.xml><?xml version="1.0" encoding="utf-8"?>
@@ -232,9 +149,10 @@
           <a:lstStyle/>
           <a:p>
             <a:r>
-              <a:rPr lang="en-US"/>
+              <a:rPr lang="en-US" smtClean="0"/>
               <a:t>Click to edit Master title style</a:t>
             </a:r>
+            <a:endParaRPr lang="en-US"/>
           </a:p>
         </p:txBody>
       </p:sp>
@@ -350,9 +268,10 @@
           </a:lstStyle>
           <a:p>
             <a:r>
-              <a:rPr lang="en-US"/>
+              <a:rPr lang="en-US" smtClean="0"/>
               <a:t>Click to edit Master subtitle style</a:t>
             </a:r>
+            <a:endParaRPr lang="en-US"/>
           </a:p>
         </p:txBody>
       </p:sp>
@@ -373,7 +292,7 @@
           <a:p>
             <a:fld id="{5BCAD085-E8A6-8845-BD4E-CB4CCA059FC4}" type="datetimeFigureOut">
               <a:rPr lang="en-US" smtClean="0"/>
-              <a:t>10/14/2026</a:t>
+              <a:t>1/27/13</a:t>
             </a:fld>
             <a:endParaRPr lang="en-US"/>
           </a:p>
@@ -467,9 +386,10 @@
           <a:lstStyle/>
           <a:p>
             <a:r>
-              <a:rPr lang="en-US"/>
+              <a:rPr lang="en-US" smtClean="0"/>
               <a:t>Click to edit Master title style</a:t>
             </a:r>
+            <a:endParaRPr lang="en-US"/>
           </a:p>
         </p:txBody>
       </p:sp>
@@ -490,37 +410,38 @@
           <a:p>
             <a:pPr lvl="0"/>
             <a:r>
-              <a:rPr lang="en-US"/>
+              <a:rPr lang="en-US" smtClean="0"/>
               <a:t>Click to edit Master text styles</a:t>
             </a:r>
           </a:p>
           <a:p>
             <a:pPr lvl="1"/>
             <a:r>
-              <a:rPr lang="en-US"/>
+              <a:rPr lang="en-US" smtClean="0"/>
               <a:t>Second level</a:t>
             </a:r>
           </a:p>
           <a:p>
             <a:pPr lvl="2"/>
             <a:r>
-              <a:rPr lang="en-US"/>
+              <a:rPr lang="en-US" smtClean="0"/>
               <a:t>Third level</a:t>
             </a:r>
           </a:p>
           <a:p>
             <a:pPr lvl="3"/>
             <a:r>
-              <a:rPr lang="en-US"/>
+              <a:rPr lang="en-US" smtClean="0"/>
               <a:t>Fourth level</a:t>
             </a:r>
           </a:p>
           <a:p>
             <a:pPr lvl="4"/>
             <a:r>
-              <a:rPr lang="en-US"/>
+              <a:rPr lang="en-US" smtClean="0"/>
               <a:t>Fifth level</a:t>
             </a:r>
+            <a:endParaRPr lang="en-US"/>
           </a:p>
         </p:txBody>
       </p:sp>
@@ -541,7 +462,7 @@
           <a:p>
             <a:fld id="{5BCAD085-E8A6-8845-BD4E-CB4CCA059FC4}" type="datetimeFigureOut">
               <a:rPr lang="en-US" smtClean="0"/>
-              <a:t>10/14/2026</a:t>
+              <a:t>1/27/13</a:t>
             </a:fld>
             <a:endParaRPr lang="en-US"/>
           </a:p>
@@ -640,9 +561,10 @@
           <a:lstStyle/>
           <a:p>
             <a:r>
-              <a:rPr lang="en-US"/>
+              <a:rPr lang="en-US" smtClean="0"/>
               <a:t>Click to edit Master title style</a:t>
             </a:r>
+            <a:endParaRPr lang="en-US"/>
           </a:p>
         </p:txBody>
       </p:sp>
@@ -668,37 +590,38 @@
           <a:p>
             <a:pPr lvl="0"/>
             <a:r>
-              <a:rPr lang="en-US"/>
+              <a:rPr lang="en-US" smtClean="0"/>
               <a:t>Click to edit Master text styles</a:t>
             </a:r>
           </a:p>
           <a:p>
             <a:pPr lvl="1"/>
             <a:r>
-              <a:rPr lang="en-US"/>
+              <a:rPr lang="en-US" smtClean="0"/>
               <a:t>Second level</a:t>
             </a:r>
           </a:p>
           <a:p>
             <a:pPr lvl="2"/>
             <a:r>
-              <a:rPr lang="en-US"/>
+              <a:rPr lang="en-US" smtClean="0"/>
               <a:t>Third level</a:t>
             </a:r>
           </a:p>
           <a:p>
             <a:pPr lvl="3"/>
             <a:r>
-              <a:rPr lang="en-US"/>
+              <a:rPr lang="en-US" smtClean="0"/>
               <a:t>Fourth level</a:t>
             </a:r>
           </a:p>
           <a:p>
             <a:pPr lvl="4"/>
             <a:r>
-              <a:rPr lang="en-US"/>
+              <a:rPr lang="en-US" smtClean="0"/>
               <a:t>Fifth level</a:t>
             </a:r>
+            <a:endParaRPr lang="en-US"/>
           </a:p>
         </p:txBody>
       </p:sp>
@@ -719,7 +642,7 @@
           <a:p>
             <a:fld id="{5BCAD085-E8A6-8845-BD4E-CB4CCA059FC4}" type="datetimeFigureOut">
               <a:rPr lang="en-US" smtClean="0"/>
-              <a:t>10/14/2026</a:t>
+              <a:t>1/27/13</a:t>
             </a:fld>
             <a:endParaRPr lang="en-US"/>
           </a:p>
@@ -813,9 +736,10 @@
           <a:lstStyle/>
           <a:p>
             <a:r>
-              <a:rPr lang="en-US"/>
+              <a:rPr lang="en-US" smtClean="0"/>
               <a:t>Click to edit Master title style</a:t>
             </a:r>
+            <a:endParaRPr lang="en-US"/>
           </a:p>
         </p:txBody>
       </p:sp>
@@ -836,37 +760,38 @@
           <a:p>
             <a:pPr lvl="0"/>
             <a:r>
-              <a:rPr lang="en-US"/>
+              <a:rPr lang="en-US" smtClean="0"/>
               <a:t>Click to edit Master text styles</a:t>
             </a:r>
           </a:p>
           <a:p>
             <a:pPr lvl="1"/>
             <a:r>
-              <a:rPr lang="en-US"/>
+              <a:rPr lang="en-US" smtClean="0"/>
               <a:t>Second level</a:t>
             </a:r>
           </a:p>
           <a:p>
             <a:pPr lvl="2"/>
             <a:r>
-              <a:rPr lang="en-US"/>
+              <a:rPr lang="en-US" smtClean="0"/>
               <a:t>Third level</a:t>
             </a:r>
           </a:p>
           <a:p>
             <a:pPr lvl="3"/>
             <a:r>
-              <a:rPr lang="en-US"/>
+              <a:rPr lang="en-US" smtClean="0"/>
               <a:t>Fourth level</a:t>
             </a:r>
           </a:p>
           <a:p>
             <a:pPr lvl="4"/>
             <a:r>
-              <a:rPr lang="en-US"/>
+              <a:rPr lang="en-US" smtClean="0"/>
               <a:t>Fifth level</a:t>
             </a:r>
+            <a:endParaRPr lang="en-US"/>
           </a:p>
         </p:txBody>
       </p:sp>
@@ -887,7 +812,7 @@
           <a:p>
             <a:fld id="{5BCAD085-E8A6-8845-BD4E-CB4CCA059FC4}" type="datetimeFigureOut">
               <a:rPr lang="en-US" smtClean="0"/>
-              <a:t>10/14/2026</a:t>
+              <a:t>1/27/13</a:t>
             </a:fld>
             <a:endParaRPr lang="en-US"/>
           </a:p>
@@ -990,9 +915,10 @@
           </a:lstStyle>
           <a:p>
             <a:r>
-              <a:rPr lang="en-US"/>
+              <a:rPr lang="en-US" smtClean="0"/>
               <a:t>Click to edit Master title style</a:t>
             </a:r>
+            <a:endParaRPr lang="en-US"/>
           </a:p>
         </p:txBody>
       </p:sp>
@@ -1109,7 +1035,7 @@
           <a:p>
             <a:pPr lvl="0"/>
             <a:r>
-              <a:rPr lang="en-US"/>
+              <a:rPr lang="en-US" smtClean="0"/>
               <a:t>Click to edit Master text styles</a:t>
             </a:r>
           </a:p>
@@ -1132,7 +1058,7 @@
           <a:p>
             <a:fld id="{5BCAD085-E8A6-8845-BD4E-CB4CCA059FC4}" type="datetimeFigureOut">
               <a:rPr lang="en-US" smtClean="0"/>
-              <a:t>10/14/2026</a:t>
+              <a:t>1/27/13</a:t>
             </a:fld>
             <a:endParaRPr lang="en-US"/>
           </a:p>
@@ -1226,9 +1152,10 @@
           <a:lstStyle/>
           <a:p>
             <a:r>
-              <a:rPr lang="en-US"/>
+              <a:rPr lang="en-US" smtClean="0"/>
               <a:t>Click to edit Master title style</a:t>
             </a:r>
+            <a:endParaRPr lang="en-US"/>
           </a:p>
         </p:txBody>
       </p:sp>
@@ -1282,37 +1209,38 @@
           <a:p>
             <a:pPr lvl="0"/>
             <a:r>
-              <a:rPr lang="en-US"/>
+              <a:rPr lang="en-US" smtClean="0"/>
               <a:t>Click to edit Master text styles</a:t>
             </a:r>
           </a:p>
           <a:p>
             <a:pPr lvl="1"/>
             <a:r>
-              <a:rPr lang="en-US"/>
+              <a:rPr lang="en-US" smtClean="0"/>
               <a:t>Second level</a:t>
             </a:r>
           </a:p>
           <a:p>
             <a:pPr lvl="2"/>
             <a:r>
-              <a:rPr lang="en-US"/>
+              <a:rPr lang="en-US" smtClean="0"/>
               <a:t>Third level</a:t>
             </a:r>
           </a:p>
           <a:p>
             <a:pPr lvl="3"/>
             <a:r>
-              <a:rPr lang="en-US"/>
+              <a:rPr lang="en-US" smtClean="0"/>
               <a:t>Fourth level</a:t>
             </a:r>
           </a:p>
           <a:p>
             <a:pPr lvl="4"/>
             <a:r>
-              <a:rPr lang="en-US"/>
+              <a:rPr lang="en-US" smtClean="0"/>
               <a:t>Fifth level</a:t>
             </a:r>
+            <a:endParaRPr lang="en-US"/>
           </a:p>
         </p:txBody>
       </p:sp>
@@ -1366,37 +1294,38 @@
           <a:p>
             <a:pPr lvl="0"/>
             <a:r>
-              <a:rPr lang="en-US"/>
+              <a:rPr lang="en-US" smtClean="0"/>
               <a:t>Click to edit Master text styles</a:t>
             </a:r>
           </a:p>
           <a:p>
             <a:pPr lvl="1"/>
             <a:r>
-              <a:rPr lang="en-US"/>
+              <a:rPr lang="en-US" smtClean="0"/>
               <a:t>Second level</a:t>
             </a:r>
           </a:p>
           <a:p>
             <a:pPr lvl="2"/>
             <a:r>
-              <a:rPr lang="en-US"/>
+              <a:rPr lang="en-US" smtClean="0"/>
               <a:t>Third level</a:t>
             </a:r>
           </a:p>
           <a:p>
             <a:pPr lvl="3"/>
             <a:r>
-              <a:rPr lang="en-US"/>
+              <a:rPr lang="en-US" smtClean="0"/>
               <a:t>Fourth level</a:t>
             </a:r>
           </a:p>
           <a:p>
             <a:pPr lvl="4"/>
             <a:r>
-              <a:rPr lang="en-US"/>
+              <a:rPr lang="en-US" smtClean="0"/>
               <a:t>Fifth level</a:t>
             </a:r>
+            <a:endParaRPr lang="en-US"/>
           </a:p>
         </p:txBody>
       </p:sp>
@@ -1417,7 +1346,7 @@
           <a:p>
             <a:fld id="{5BCAD085-E8A6-8845-BD4E-CB4CCA059FC4}" type="datetimeFigureOut">
               <a:rPr lang="en-US" smtClean="0"/>
-              <a:t>10/14/2026</a:t>
+              <a:t>1/27/13</a:t>
             </a:fld>
             <a:endParaRPr lang="en-US"/>
           </a:p>
@@ -1515,9 +1444,10 @@
           </a:lstStyle>
           <a:p>
             <a:r>
-              <a:rPr lang="en-US"/>
+              <a:rPr lang="en-US" smtClean="0"/>
               <a:t>Click to edit Master title style</a:t>
             </a:r>
+            <a:endParaRPr lang="en-US"/>
           </a:p>
         </p:txBody>
       </p:sp>
@@ -1580,7 +1510,7 @@
           <a:p>
             <a:pPr lvl="0"/>
             <a:r>
-              <a:rPr lang="en-US"/>
+              <a:rPr lang="en-US" smtClean="0"/>
               <a:t>Click to edit Master text styles</a:t>
             </a:r>
           </a:p>
@@ -1636,37 +1566,38 @@
           <a:p>
             <a:pPr lvl="0"/>
             <a:r>
-              <a:rPr lang="en-US"/>
+              <a:rPr lang="en-US" smtClean="0"/>
               <a:t>Click to edit Master text styles</a:t>
             </a:r>
           </a:p>
           <a:p>
             <a:pPr lvl="1"/>
             <a:r>
-              <a:rPr lang="en-US"/>
+              <a:rPr lang="en-US" smtClean="0"/>
               <a:t>Second level</a:t>
             </a:r>
           </a:p>
           <a:p>
             <a:pPr lvl="2"/>
             <a:r>
-              <a:rPr lang="en-US"/>
+              <a:rPr lang="en-US" smtClean="0"/>
               <a:t>Third level</a:t>
             </a:r>
           </a:p>
           <a:p>
             <a:pPr lvl="3"/>
             <a:r>
-              <a:rPr lang="en-US"/>
+              <a:rPr lang="en-US" smtClean="0"/>
               <a:t>Fourth level</a:t>
             </a:r>
           </a:p>
           <a:p>
             <a:pPr lvl="4"/>
             <a:r>
-              <a:rPr lang="en-US"/>
+              <a:rPr lang="en-US" smtClean="0"/>
               <a:t>Fifth level</a:t>
             </a:r>
+            <a:endParaRPr lang="en-US"/>
           </a:p>
         </p:txBody>
       </p:sp>
@@ -1729,7 +1660,7 @@
           <a:p>
             <a:pPr lvl="0"/>
             <a:r>
-              <a:rPr lang="en-US"/>
+              <a:rPr lang="en-US" smtClean="0"/>
               <a:t>Click to edit Master text styles</a:t>
             </a:r>
           </a:p>
@@ -1785,37 +1716,38 @@
           <a:p>
             <a:pPr lvl="0"/>
             <a:r>
-              <a:rPr lang="en-US"/>
+              <a:rPr lang="en-US" smtClean="0"/>
               <a:t>Click to edit Master text styles</a:t>
             </a:r>
           </a:p>
           <a:p>
             <a:pPr lvl="1"/>
             <a:r>
-              <a:rPr lang="en-US"/>
+              <a:rPr lang="en-US" smtClean="0"/>
               <a:t>Second level</a:t>
             </a:r>
           </a:p>
           <a:p>
             <a:pPr lvl="2"/>
             <a:r>
-              <a:rPr lang="en-US"/>
+              <a:rPr lang="en-US" smtClean="0"/>
               <a:t>Third level</a:t>
             </a:r>
           </a:p>
           <a:p>
             <a:pPr lvl="3"/>
             <a:r>
-              <a:rPr lang="en-US"/>
+              <a:rPr lang="en-US" smtClean="0"/>
               <a:t>Fourth level</a:t>
             </a:r>
           </a:p>
           <a:p>
             <a:pPr lvl="4"/>
             <a:r>
-              <a:rPr lang="en-US"/>
+              <a:rPr lang="en-US" smtClean="0"/>
               <a:t>Fifth level</a:t>
             </a:r>
+            <a:endParaRPr lang="en-US"/>
           </a:p>
         </p:txBody>
       </p:sp>
@@ -1836,7 +1768,7 @@
           <a:p>
             <a:fld id="{5BCAD085-E8A6-8845-BD4E-CB4CCA059FC4}" type="datetimeFigureOut">
               <a:rPr lang="en-US" smtClean="0"/>
-              <a:t>10/14/2026</a:t>
+              <a:t>1/27/13</a:t>
             </a:fld>
             <a:endParaRPr lang="en-US"/>
           </a:p>
@@ -1930,9 +1862,10 @@
           <a:lstStyle/>
           <a:p>
             <a:r>
-              <a:rPr lang="en-US"/>
+              <a:rPr lang="en-US" smtClean="0"/>
               <a:t>Click to edit Master title style</a:t>
             </a:r>
+            <a:endParaRPr lang="en-US"/>
           </a:p>
         </p:txBody>
       </p:sp>
@@ -1953,7 +1886,7 @@
           <a:p>
             <a:fld id="{5BCAD085-E8A6-8845-BD4E-CB4CCA059FC4}" type="datetimeFigureOut">
               <a:rPr lang="en-US" smtClean="0"/>
-              <a:t>10/14/2026</a:t>
+              <a:t>1/27/13</a:t>
             </a:fld>
             <a:endParaRPr lang="en-US"/>
           </a:p>
@@ -2048,7 +1981,7 @@
           <a:p>
             <a:fld id="{5BCAD085-E8A6-8845-BD4E-CB4CCA059FC4}" type="datetimeFigureOut">
               <a:rPr lang="en-US" smtClean="0"/>
-              <a:t>10/14/2026</a:t>
+              <a:t>1/27/13</a:t>
             </a:fld>
             <a:endParaRPr lang="en-US"/>
           </a:p>
@@ -2151,9 +2084,10 @@
           </a:lstStyle>
           <a:p>
             <a:r>
-              <a:rPr lang="en-US"/>
+              <a:rPr lang="en-US" smtClean="0"/>
               <a:t>Click to edit Master title style</a:t>
             </a:r>
+            <a:endParaRPr lang="en-US"/>
           </a:p>
         </p:txBody>
       </p:sp>
@@ -2207,37 +2141,38 @@
           <a:p>
             <a:pPr lvl="0"/>
             <a:r>
-              <a:rPr lang="en-US"/>
+              <a:rPr lang="en-US" smtClean="0"/>
               <a:t>Click to edit Master text styles</a:t>
             </a:r>
           </a:p>
           <a:p>
             <a:pPr lvl="1"/>
             <a:r>
-              <a:rPr lang="en-US"/>
+              <a:rPr lang="en-US" smtClean="0"/>
               <a:t>Second level</a:t>
             </a:r>
           </a:p>
           <a:p>
             <a:pPr lvl="2"/>
             <a:r>
-              <a:rPr lang="en-US"/>
+              <a:rPr lang="en-US" smtClean="0"/>
               <a:t>Third level</a:t>
             </a:r>
           </a:p>
           <a:p>
             <a:pPr lvl="3"/>
             <a:r>
-              <a:rPr lang="en-US"/>
+              <a:rPr lang="en-US" smtClean="0"/>
               <a:t>Fourth level</a:t>
             </a:r>
           </a:p>
           <a:p>
             <a:pPr lvl="4"/>
             <a:r>
-              <a:rPr lang="en-US"/>
+              <a:rPr lang="en-US" smtClean="0"/>
               <a:t>Fifth level</a:t>
             </a:r>
+            <a:endParaRPr lang="en-US"/>
           </a:p>
         </p:txBody>
       </p:sp>
@@ -2300,7 +2235,7 @@
           <a:p>
             <a:pPr lvl="0"/>
             <a:r>
-              <a:rPr lang="en-US"/>
+              <a:rPr lang="en-US" smtClean="0"/>
               <a:t>Click to edit Master text styles</a:t>
             </a:r>
           </a:p>
@@ -2323,7 +2258,7 @@
           <a:p>
             <a:fld id="{5BCAD085-E8A6-8845-BD4E-CB4CCA059FC4}" type="datetimeFigureOut">
               <a:rPr lang="en-US" smtClean="0"/>
-              <a:t>10/14/2026</a:t>
+              <a:t>1/27/13</a:t>
             </a:fld>
             <a:endParaRPr lang="en-US"/>
           </a:p>
@@ -2426,9 +2361,10 @@
           </a:lstStyle>
           <a:p>
             <a:r>
-              <a:rPr lang="en-US"/>
+              <a:rPr lang="en-US" smtClean="0"/>
               <a:t>Click to edit Master title style</a:t>
             </a:r>
+            <a:endParaRPr lang="en-US"/>
           </a:p>
         </p:txBody>
       </p:sp>
@@ -2552,7 +2488,7 @@
           <a:p>
             <a:pPr lvl="0"/>
             <a:r>
-              <a:rPr lang="en-US"/>
+              <a:rPr lang="en-US" smtClean="0"/>
               <a:t>Click to edit Master text styles</a:t>
             </a:r>
           </a:p>
@@ -2575,7 +2511,7 @@
           <a:p>
             <a:fld id="{5BCAD085-E8A6-8845-BD4E-CB4CCA059FC4}" type="datetimeFigureOut">
               <a:rPr lang="en-US" smtClean="0"/>
-              <a:t>10/14/2026</a:t>
+              <a:t>1/27/13</a:t>
             </a:fld>
             <a:endParaRPr lang="en-US"/>
           </a:p>
@@ -2684,9 +2620,10 @@
           <a:lstStyle/>
           <a:p>
             <a:r>
-              <a:rPr lang="en-US"/>
+              <a:rPr lang="en-US" smtClean="0"/>
               <a:t>Click to edit Master title style</a:t>
             </a:r>
+            <a:endParaRPr lang="en-US"/>
           </a:p>
         </p:txBody>
       </p:sp>
@@ -2717,37 +2654,38 @@
           <a:p>
             <a:pPr lvl="0"/>
             <a:r>
-              <a:rPr lang="en-US"/>
+              <a:rPr lang="en-US" smtClean="0"/>
               <a:t>Click to edit Master text styles</a:t>
             </a:r>
           </a:p>
           <a:p>
             <a:pPr lvl="1"/>
             <a:r>
-              <a:rPr lang="en-US"/>
+              <a:rPr lang="en-US" smtClean="0"/>
               <a:t>Second level</a:t>
             </a:r>
           </a:p>
           <a:p>
             <a:pPr lvl="2"/>
             <a:r>
-              <a:rPr lang="en-US"/>
+              <a:rPr lang="en-US" smtClean="0"/>
               <a:t>Third level</a:t>
             </a:r>
           </a:p>
           <a:p>
             <a:pPr lvl="3"/>
             <a:r>
-              <a:rPr lang="en-US"/>
+              <a:rPr lang="en-US" smtClean="0"/>
               <a:t>Fourth level</a:t>
             </a:r>
           </a:p>
           <a:p>
             <a:pPr lvl="4"/>
             <a:r>
-              <a:rPr lang="en-US"/>
+              <a:rPr lang="en-US" smtClean="0"/>
               <a:t>Fifth level</a:t>
             </a:r>
+            <a:endParaRPr lang="en-US"/>
           </a:p>
         </p:txBody>
       </p:sp>
@@ -2786,7 +2724,7 @@
           <a:p>
             <a:fld id="{5BCAD085-E8A6-8845-BD4E-CB4CCA059FC4}" type="datetimeFigureOut">
               <a:rPr lang="en-US" smtClean="0"/>
-              <a:t>10/14/2026</a:t>
+              <a:t>1/27/13</a:t>
             </a:fld>
             <a:endParaRPr lang="en-US"/>
           </a:p>
@@ -3145,30 +3083,15 @@
 </file>
 
 <file path=ppt/slides/slide1.xml><?xml version="1.0" encoding="utf-8"?>
-<p:sld xmlns:a="http://schemas.openxmlformats.org/drawingml/2006/main" xmlns:r="http://schemas.openxmlformats.org/officeDocument/2006/relationships" xmlns:p="http://schemas.openxmlformats.org/presentationml/2006/main">
+<p:sld xmlns:a="http://schemas.openxmlformats.org/drawingml/2006/main" xmlns:p="http://schemas.openxmlformats.org/presentationml/2006/main" xmlns:r="http://schemas.openxmlformats.org/officeDocument/2006/relationships">
   <p:cSld>
-    <p:bg>
-      <p:bgPr>
-        <a:solidFill>
-          <a:srgbClr val="0D1B2A"/>
-        </a:solidFill>
-        <a:effectLst/>
-      </p:bgPr>
-    </p:bg>
     <p:spTree>
       <p:nvGrpSpPr>
         <p:cNvPr id="1" name=""/>
         <p:cNvGrpSpPr/>
         <p:nvPr/>
       </p:nvGrpSpPr>
-      <p:grpSpPr>
-        <a:xfrm>
-          <a:off x="0" y="0"/>
-          <a:ext cx="0" cy="0"/>
-          <a:chOff x="0" y="0"/>
-          <a:chExt cx="0" cy="0"/>
-        </a:xfrm>
-      </p:grpSpPr>
+      <p:grpSpPr/>
       <p:sp>
         <p:nvSpPr>
           <p:cNvPr id="2" name="Rectangle 1"/>
@@ -3177,14 +3100,14 @@
         </p:nvSpPr>
         <p:spPr>
           <a:xfrm>
-            <a:off x="0" y="2560320"/>
-            <a:ext cx="12191695" cy="54864"/>
+            <a:off x="0" y="0"/>
+            <a:ext cx="12191695" cy="6858000"/>
           </a:xfrm>
           <a:prstGeom prst="rect">
             <a:avLst/>
           </a:prstGeom>
           <a:solidFill>
-            <a:srgbClr val="4472C4"/>
+            <a:srgbClr val="0F172A"/>
           </a:solidFill>
           <a:ln>
             <a:noFill/>
@@ -3209,7 +3132,6 @@
           <a:lstStyle/>
           <a:p>
             <a:pPr algn="ctr"/>
-            <a:endParaRPr/>
           </a:p>
         </p:txBody>
       </p:sp>
@@ -3222,7 +3144,7 @@
         <p:spPr>
           <a:xfrm>
             <a:off x="914400" y="1097280"/>
-            <a:ext cx="10058400" cy="1097280"/>
+            <a:ext cx="10332720" cy="1371600"/>
           </a:xfrm>
           <a:prstGeom prst="rect">
             <a:avLst/>
@@ -3230,153 +3152,56 @@
           <a:noFill/>
         </p:spPr>
         <p:txBody>
-          <a:bodyPr wrap="square">
+          <a:bodyPr wrap="none">
             <a:spAutoFit/>
           </a:bodyPr>
           <a:lstStyle/>
           <a:p>
-            <a:pPr algn="ctr">
+            <a:pPr>
               <a:defRPr sz="4000" b="1">
                 <a:solidFill>
-                  <a:srgbClr val="FFFFFF"/>
-                </a:solidFill>
-                <a:latin typeface="Calibri"/>
+                  <a:srgbClr val="F1F5F9"/>
+                </a:solidFill>
               </a:defRPr>
             </a:pPr>
             <a:r>
-              <a:t>COVID-19 GLOBAL DATA EXPLORER</a:t>
-            </a:r>
-          </a:p>
-        </p:txBody>
-      </p:sp>
-      <p:sp>
-        <p:nvSpPr>
-          <p:cNvPr id="4" name="TextBox 3"/>
-          <p:cNvSpPr txBox="1"/>
+              <a:t>COVID-19 Global Data Explorer</a:t>
+            </a:r>
+          </a:p>
+          <a:p>
+            <a:pPr>
+              <a:defRPr sz="1800">
+                <a:solidFill>
+                  <a:srgbClr val="3B82F6"/>
+                </a:solidFill>
+              </a:defRPr>
+            </a:pPr>
+            <a:r>
+              <a:t>Data Visualization Techniques (LA-2) | Public Health Analytical Project | Group 2</a:t>
+            </a:r>
+          </a:p>
+        </p:txBody>
+      </p:sp>
+      <p:sp>
+        <p:nvSpPr>
+          <p:cNvPr id="4" name="Rounded Rectangle 3"/>
+          <p:cNvSpPr/>
           <p:nvPr/>
         </p:nvSpPr>
         <p:spPr>
           <a:xfrm>
-            <a:off x="914400" y="2011680"/>
-            <a:ext cx="10058400" cy="548640"/>
-          </a:xfrm>
-          <a:prstGeom prst="rect">
-            <a:avLst/>
-          </a:prstGeom>
-          <a:noFill/>
-        </p:spPr>
-        <p:txBody>
-          <a:bodyPr wrap="square">
-            <a:spAutoFit/>
-          </a:bodyPr>
-          <a:lstStyle/>
-          <a:p>
-            <a:pPr algn="ctr">
-              <a:defRPr sz="1800" b="0">
-                <a:solidFill>
-                  <a:srgbClr val="4472C4"/>
-                </a:solidFill>
-                <a:latin typeface="Calibri"/>
-              </a:defRPr>
-            </a:pPr>
-            <a:r>
-              <a:t>Data Visualization Techniques  |  Public Health Project  |  Group 2</a:t>
-            </a:r>
-          </a:p>
-        </p:txBody>
-      </p:sp>
-      <p:sp>
-        <p:nvSpPr>
-          <p:cNvPr id="5" name="TextBox 4"/>
-          <p:cNvSpPr txBox="1"/>
-          <p:nvPr/>
-        </p:nvSpPr>
-        <p:spPr>
-          <a:xfrm>
-            <a:off x="1828800" y="3200400"/>
-            <a:ext cx="8229600" cy="365760"/>
-          </a:xfrm>
-          <a:prstGeom prst="rect">
-            <a:avLst/>
-          </a:prstGeom>
-          <a:noFill/>
-        </p:spPr>
-        <p:txBody>
-          <a:bodyPr wrap="square">
-            <a:spAutoFit/>
-          </a:bodyPr>
-          <a:lstStyle/>
-          <a:p>
-            <a:pPr algn="ctr">
-              <a:defRPr sz="1600" b="0">
-                <a:solidFill>
-                  <a:srgbClr val="C8C8C8"/>
-                </a:solidFill>
-                <a:latin typeface="Calibri"/>
-              </a:defRPr>
-            </a:pPr>
-            <a:r>
-              <a:t>Aashi Kohad (02)   •   Himanshu Yadav (20)   •   Nishant Giri (37)   •   Shreyash Karemore (55)</a:t>
-            </a:r>
-          </a:p>
-        </p:txBody>
-      </p:sp>
-      <p:sp>
-        <p:nvSpPr>
-          <p:cNvPr id="6" name="TextBox 5"/>
-          <p:cNvSpPr txBox="1"/>
-          <p:nvPr/>
-        </p:nvSpPr>
-        <p:spPr>
-          <a:xfrm>
-            <a:off x="1828800" y="4114800"/>
-            <a:ext cx="8229600" cy="365760"/>
-          </a:xfrm>
-          <a:prstGeom prst="rect">
-            <a:avLst/>
-          </a:prstGeom>
-          <a:noFill/>
-        </p:spPr>
-        <p:txBody>
-          <a:bodyPr wrap="square">
-            <a:spAutoFit/>
-          </a:bodyPr>
-          <a:lstStyle/>
-          <a:p>
-            <a:pPr algn="ctr">
-              <a:defRPr sz="1400" b="0">
-                <a:solidFill>
-                  <a:srgbClr val="969696"/>
-                </a:solidFill>
-                <a:latin typeface="Calibri"/>
-              </a:defRPr>
-            </a:pPr>
-            <a:r>
-              <a:t>Submission: 14 October 2026   |   LA-2: 15 October 2026   |   Speaking Time: 2 min</a:t>
-            </a:r>
-          </a:p>
-        </p:txBody>
-      </p:sp>
-      <p:sp>
-        <p:nvSpPr>
-          <p:cNvPr id="7" name="Rounded Rectangle 6"/>
-          <p:cNvSpPr/>
-          <p:nvPr/>
-        </p:nvSpPr>
-        <p:spPr>
-          <a:xfrm>
-            <a:off x="1828800" y="4846320"/>
-            <a:ext cx="8503920" cy="1097280"/>
+            <a:off x="914400" y="2743200"/>
+            <a:ext cx="10332720" cy="1005840"/>
           </a:xfrm>
           <a:prstGeom prst="roundRect">
             <a:avLst/>
           </a:prstGeom>
           <a:solidFill>
-            <a:srgbClr val="1B3A5C"/>
+            <a:srgbClr val="1E293B"/>
           </a:solidFill>
-          <a:ln w="12700">
+          <a:ln>
             <a:solidFill>
-              <a:srgbClr val="4472C4"/>
+              <a:srgbClr val="3B82F6"/>
             </a:solidFill>
           </a:ln>
         </p:spPr>
@@ -3395,19 +3220,132 @@
           </a:fontRef>
         </p:style>
         <p:txBody>
-          <a:bodyPr wrap="square" rtlCol="0" anchor="ctr"/>
+          <a:bodyPr rtlCol="0" anchor="ctr"/>
           <a:lstStyle/>
           <a:p>
             <a:pPr algn="ctr">
+              <a:defRPr sz="1600" b="1">
+                <a:solidFill>
+                  <a:srgbClr val="22C55E"/>
+                </a:solidFill>
+              </a:defRPr>
+            </a:pPr>
+            <a:r>
+              <a:t>🌐 Live Interactive Dashboard: https://covid19-global-data-explorer-lqpxjhstcgzwc7gxhnshtd.streamlit.app/</a:t>
+            </a:r>
+          </a:p>
+          <a:p>
+            <a:pPr>
+              <a:defRPr sz="1300">
+                <a:solidFill>
+                  <a:srgbClr val="94A3B8"/>
+                </a:solidFill>
+              </a:defRPr>
+            </a:pPr>
+            <a:r>
+              <a:t>💻 GitHub Repository: https://github.com/nishant-giri-j/covid19-global-data-explorer</a:t>
+            </a:r>
+          </a:p>
+        </p:txBody>
+      </p:sp>
+      <p:sp>
+        <p:nvSpPr>
+          <p:cNvPr id="5" name="Rounded Rectangle 4"/>
+          <p:cNvSpPr/>
+          <p:nvPr/>
+        </p:nvSpPr>
+        <p:spPr>
+          <a:xfrm>
+            <a:off x="914400" y="4114800"/>
+            <a:ext cx="10332720" cy="2011680"/>
+          </a:xfrm>
+          <a:prstGeom prst="roundRect">
+            <a:avLst/>
+          </a:prstGeom>
+          <a:solidFill>
+            <a:srgbClr val="1E293B"/>
+          </a:solidFill>
+          <a:ln>
+            <a:solidFill>
+              <a:srgbClr val="334155"/>
+            </a:solidFill>
+          </a:ln>
+        </p:spPr>
+        <p:style>
+          <a:lnRef idx="1">
+            <a:schemeClr val="accent1"/>
+          </a:lnRef>
+          <a:fillRef idx="3">
+            <a:schemeClr val="accent1"/>
+          </a:fillRef>
+          <a:effectRef idx="2">
+            <a:schemeClr val="accent1"/>
+          </a:effectRef>
+          <a:fontRef idx="minor">
+            <a:schemeClr val="lt1"/>
+          </a:fontRef>
+        </p:style>
+        <p:txBody>
+          <a:bodyPr rtlCol="0" anchor="ctr"/>
+          <a:lstStyle/>
+          <a:p>
+            <a:pPr algn="ctr">
+              <a:defRPr b="1" sz="1600">
+                <a:solidFill>
+                  <a:srgbClr val="F1F5F9"/>
+                </a:solidFill>
+              </a:defRPr>
+            </a:pPr>
+            <a:r>
+              <a:t>Group 2 Members:</a:t>
+            </a:r>
+          </a:p>
+          <a:p>
+            <a:pPr>
               <a:defRPr sz="1400">
                 <a:solidFill>
-                  <a:srgbClr val="C8C8C8"/>
-                </a:solidFill>
-                <a:latin typeface="Calibri"/>
+                  <a:srgbClr val="94A3B8"/>
+                </a:solidFill>
               </a:defRPr>
             </a:pPr>
             <a:r>
-              <a:t>Objective: Transform raw COVID-19 data into interactive visualizations that reveal global trends, regional disparities, and actionable insights for public health decision-making.</a:t>
+              <a:t>• Roll No. 02: Aashi Kohad — Dataset Discovery &amp; Analytical Storytelling</a:t>
+            </a:r>
+          </a:p>
+          <a:p>
+            <a:pPr>
+              <a:defRPr sz="1400">
+                <a:solidFill>
+                  <a:srgbClr val="94A3B8"/>
+                </a:solidFill>
+              </a:defRPr>
+            </a:pPr>
+            <a:r>
+              <a:t>• Roll No. 20: Himanshu Yadav — Analytical Questions &amp; Visualization Selection</a:t>
+            </a:r>
+          </a:p>
+          <a:p>
+            <a:pPr>
+              <a:defRPr sz="1400">
+                <a:solidFill>
+                  <a:srgbClr val="94A3B8"/>
+                </a:solidFill>
+              </a:defRPr>
+            </a:pPr>
+            <a:r>
+              <a:t>• Roll No. 37: Nishant Giri — Dashboard Development &amp; Cloud Deployment</a:t>
+            </a:r>
+          </a:p>
+          <a:p>
+            <a:pPr>
+              <a:defRPr sz="1400">
+                <a:solidFill>
+                  <a:srgbClr val="94A3B8"/>
+                </a:solidFill>
+              </a:defRPr>
+            </a:pPr>
+            <a:r>
+              <a:t>• Roll No. 55: Shreyash Karemore — Wrong Viz Challenge &amp; AI Critic Evaluation</a:t>
             </a:r>
           </a:p>
         </p:txBody>
@@ -3421,82 +3359,31 @@
 </file>
 
 <file path=ppt/slides/slide2.xml><?xml version="1.0" encoding="utf-8"?>
-<p:sld xmlns:a="http://schemas.openxmlformats.org/drawingml/2006/main" xmlns:r="http://schemas.openxmlformats.org/officeDocument/2006/relationships" xmlns:p="http://schemas.openxmlformats.org/presentationml/2006/main">
+<p:sld xmlns:a="http://schemas.openxmlformats.org/drawingml/2006/main" xmlns:p="http://schemas.openxmlformats.org/presentationml/2006/main" xmlns:r="http://schemas.openxmlformats.org/officeDocument/2006/relationships">
   <p:cSld>
-    <p:bg>
-      <p:bgPr>
-        <a:solidFill>
-          <a:srgbClr val="0D1B2A"/>
-        </a:solidFill>
-        <a:effectLst/>
-      </p:bgPr>
-    </p:bg>
     <p:spTree>
       <p:nvGrpSpPr>
         <p:cNvPr id="1" name=""/>
         <p:cNvGrpSpPr/>
         <p:nvPr/>
       </p:nvGrpSpPr>
-      <p:grpSpPr>
-        <a:xfrm>
-          <a:off x="0" y="0"/>
-          <a:ext cx="0" cy="0"/>
-          <a:chOff x="0" y="0"/>
-          <a:chExt cx="0" cy="0"/>
-        </a:xfrm>
-      </p:grpSpPr>
-      <p:sp>
-        <p:nvSpPr>
-          <p:cNvPr id="2" name="TextBox 1"/>
-          <p:cNvSpPr txBox="1"/>
+      <p:grpSpPr/>
+      <p:sp>
+        <p:nvSpPr>
+          <p:cNvPr id="2" name="Rectangle 1"/>
+          <p:cNvSpPr/>
           <p:nvPr/>
         </p:nvSpPr>
         <p:spPr>
           <a:xfrm>
-            <a:off x="457200" y="274320"/>
-            <a:ext cx="10972800" cy="640080"/>
+            <a:off x="0" y="0"/>
+            <a:ext cx="12191695" cy="6858000"/>
           </a:xfrm>
           <a:prstGeom prst="rect">
             <a:avLst/>
           </a:prstGeom>
-          <a:noFill/>
-        </p:spPr>
-        <p:txBody>
-          <a:bodyPr wrap="square">
-            <a:spAutoFit/>
-          </a:bodyPr>
-          <a:lstStyle/>
-          <a:p>
-            <a:pPr algn="l">
-              <a:defRPr sz="3000" b="1">
-                <a:solidFill>
-                  <a:srgbClr val="FFFFFF"/>
-                </a:solidFill>
-                <a:latin typeface="Calibri"/>
-              </a:defRPr>
-            </a:pPr>
-            <a:r>
-              <a:t>Dataset &amp; Analytical Questions</a:t>
-            </a:r>
-          </a:p>
-        </p:txBody>
-      </p:sp>
-      <p:sp>
-        <p:nvSpPr>
-          <p:cNvPr id="3" name="Rounded Rectangle 2"/>
-          <p:cNvSpPr/>
-          <p:nvPr/>
-        </p:nvSpPr>
-        <p:spPr>
-          <a:xfrm>
-            <a:off x="457200" y="1097280"/>
-            <a:ext cx="5303520" cy="5303520"/>
-          </a:xfrm>
-          <a:prstGeom prst="roundRect">
-            <a:avLst/>
-          </a:prstGeom>
           <a:solidFill>
-            <a:srgbClr val="1B3A5C"/>
+            <a:srgbClr val="0F172A"/>
           </a:solidFill>
           <a:ln>
             <a:noFill/>
@@ -3521,20 +3408,19 @@
           <a:lstStyle/>
           <a:p>
             <a:pPr algn="ctr"/>
-            <a:endParaRPr/>
-          </a:p>
-        </p:txBody>
-      </p:sp>
-      <p:sp>
-        <p:nvSpPr>
-          <p:cNvPr id="4" name="TextBox 3"/>
+          </a:p>
+        </p:txBody>
+      </p:sp>
+      <p:sp>
+        <p:nvSpPr>
+          <p:cNvPr id="3" name="TextBox 2"/>
           <p:cNvSpPr txBox="1"/>
           <p:nvPr/>
         </p:nvSpPr>
         <p:spPr>
           <a:xfrm>
-            <a:off x="640080" y="1280160"/>
-            <a:ext cx="4937760" cy="2995692"/>
+            <a:off x="731520" y="548640"/>
+            <a:ext cx="10698480" cy="731520"/>
           </a:xfrm>
           <a:prstGeom prst="rect">
             <a:avLst/>
@@ -3542,183 +3428,45 @@
           <a:noFill/>
         </p:spPr>
         <p:txBody>
-          <a:bodyPr wrap="square">
+          <a:bodyPr wrap="none">
             <a:spAutoFit/>
           </a:bodyPr>
           <a:lstStyle/>
           <a:p>
             <a:pPr>
-              <a:spcAft>
-                <a:spcPts val="800"/>
-              </a:spcAft>
-              <a:defRPr sz="1800" b="1">
-                <a:solidFill>
-                  <a:srgbClr val="4472C4"/>
-                </a:solidFill>
-                <a:latin typeface="Calibri"/>
+              <a:defRPr sz="2800" b="1">
+                <a:solidFill>
+                  <a:srgbClr val="F1F5F9"/>
+                </a:solidFill>
               </a:defRPr>
             </a:pPr>
             <a:r>
-              <a:rPr dirty="0"/>
-              <a:t>Dataset Discovery</a:t>
-            </a:r>
-          </a:p>
-          <a:p>
-            <a:pPr>
-              <a:spcAft>
-                <a:spcPts val="400"/>
-              </a:spcAft>
-              <a:defRPr sz="1300">
-                <a:solidFill>
-                  <a:srgbClr val="C8C8C8"/>
-                </a:solidFill>
-                <a:latin typeface="Calibri"/>
-              </a:defRPr>
-            </a:pPr>
-            <a:r>
-              <a:rPr sz="1600" dirty="0"/>
-              <a:t>Source: Our World in Data (OWID) — COVID-19 Dataset</a:t>
-            </a:r>
-          </a:p>
-          <a:p>
-            <a:pPr>
-              <a:spcAft>
-                <a:spcPts val="400"/>
-              </a:spcAft>
-              <a:defRPr sz="1300">
-                <a:solidFill>
-                  <a:srgbClr val="C8C8C8"/>
-                </a:solidFill>
-                <a:latin typeface="Calibri"/>
-              </a:defRPr>
-            </a:pPr>
-            <a:r>
-              <a:rPr sz="1600" dirty="0"/>
-              <a:t>~300,000+ rows  |  67 columns  |  Jan 2020 – Aug 2024</a:t>
-            </a:r>
-          </a:p>
-          <a:p>
-            <a:pPr>
-              <a:spcAft>
-                <a:spcPts val="400"/>
-              </a:spcAft>
-              <a:defRPr sz="1300">
-                <a:solidFill>
-                  <a:srgbClr val="C8C8C8"/>
-                </a:solidFill>
-                <a:latin typeface="Calibri"/>
-              </a:defRPr>
-            </a:pPr>
-            <a:r>
-              <a:rPr sz="1600" dirty="0"/>
-              <a:t>One row per country per day</a:t>
-            </a:r>
-          </a:p>
-          <a:p>
-            <a:pPr>
-              <a:spcAft>
-                <a:spcPts val="400"/>
-              </a:spcAft>
-              <a:defRPr sz="1300">
-                <a:solidFill>
-                  <a:srgbClr val="C8C8C8"/>
-                </a:solidFill>
-                <a:latin typeface="Calibri"/>
-              </a:defRPr>
-            </a:pPr>
-            <a:r>
-              <a:rPr sz="1600" dirty="0"/>
-              <a:t>Variables: cases, deaths, vaccinations, ICU, testing, demographics</a:t>
-            </a:r>
-          </a:p>
-          <a:p>
-            <a:pPr>
-              <a:spcAft>
-                <a:spcPts val="400"/>
-              </a:spcAft>
-              <a:defRPr sz="1300">
-                <a:solidFill>
-                  <a:srgbClr val="C8C8C8"/>
-                </a:solidFill>
-                <a:latin typeface="Calibri"/>
-              </a:defRPr>
-            </a:pPr>
-            <a:r>
-              <a:rPr sz="1600" dirty="0"/>
-              <a:t>Geographical: </a:t>
-            </a:r>
-            <a:r>
-              <a:rPr sz="1600" dirty="0" err="1"/>
-              <a:t>iso_code</a:t>
-            </a:r>
-            <a:r>
-              <a:rPr sz="1600" dirty="0"/>
-              <a:t>, continent, location</a:t>
-            </a:r>
-          </a:p>
-          <a:p>
-            <a:pPr>
-              <a:spcAft>
-                <a:spcPts val="400"/>
-              </a:spcAft>
-              <a:defRPr sz="1300">
-                <a:solidFill>
-                  <a:srgbClr val="C8C8C8"/>
-                </a:solidFill>
-                <a:latin typeface="Calibri"/>
-              </a:defRPr>
-            </a:pPr>
-            <a:r>
-              <a:rPr sz="1600" dirty="0"/>
-              <a:t>Temporal: daily date granularity</a:t>
-            </a:r>
-          </a:p>
-          <a:p>
-            <a:pPr>
-              <a:spcAft>
-                <a:spcPts val="400"/>
-              </a:spcAft>
-              <a:defRPr sz="1300">
-                <a:solidFill>
-                  <a:srgbClr val="C8C8C8"/>
-                </a:solidFill>
-                <a:latin typeface="Calibri"/>
-              </a:defRPr>
-            </a:pPr>
-            <a:r>
-              <a:rPr sz="1600" dirty="0"/>
-              <a:t>Key issues: substantial </a:t>
-            </a:r>
-            <a:r>
-              <a:rPr sz="1600" dirty="0" err="1"/>
-              <a:t>NaN</a:t>
-            </a:r>
-            <a:r>
-              <a:rPr sz="1600" dirty="0"/>
-              <a:t> in vaccination &amp; hospitalization fields; OWID aggregate rows excluded</a:t>
-            </a:r>
-          </a:p>
-        </p:txBody>
-      </p:sp>
-      <p:sp>
-        <p:nvSpPr>
-          <p:cNvPr id="5" name="Rounded Rectangle 4"/>
+              <a:t>Five Analytical Questions &amp; Visualizations</a:t>
+            </a:r>
+          </a:p>
+        </p:txBody>
+      </p:sp>
+      <p:sp>
+        <p:nvSpPr>
+          <p:cNvPr id="4" name="Rounded Rectangle 3"/>
           <p:cNvSpPr/>
           <p:nvPr/>
         </p:nvSpPr>
         <p:spPr>
           <a:xfrm>
-            <a:off x="6217920" y="1097280"/>
-            <a:ext cx="5486400" cy="5303520"/>
+            <a:off x="731520" y="1463040"/>
+            <a:ext cx="10698480" cy="868680"/>
           </a:xfrm>
           <a:prstGeom prst="roundRect">
             <a:avLst/>
           </a:prstGeom>
           <a:solidFill>
-            <a:srgbClr val="1B3A5C"/>
+            <a:srgbClr val="1E293B"/>
           </a:solidFill>
           <a:ln>
-            <a:noFill/>
+            <a:solidFill>
+              <a:srgbClr val="3B82F6"/>
+            </a:solidFill>
           </a:ln>
         </p:spPr>
         <p:style>
@@ -3739,132 +3487,291 @@
           <a:bodyPr rtlCol="0" anchor="ctr"/>
           <a:lstStyle/>
           <a:p>
-            <a:pPr algn="ctr"/>
-            <a:endParaRPr/>
-          </a:p>
-        </p:txBody>
-      </p:sp>
-      <p:sp>
-        <p:nvSpPr>
-          <p:cNvPr id="6" name="TextBox 5"/>
-          <p:cNvSpPr txBox="1"/>
+            <a:pPr algn="ctr">
+              <a:defRPr b="1" sz="1400">
+                <a:solidFill>
+                  <a:srgbClr val="3B82F6"/>
+                </a:solidFill>
+              </a:defRPr>
+            </a:pPr>
+            <a:r>
+              <a:t>Q1. Wave Decoupling Dynamics  ➔  [Dual-Axis Line Chart]</a:t>
+            </a:r>
+          </a:p>
+          <a:p>
+            <a:pPr>
+              <a:defRPr sz="1200">
+                <a:solidFill>
+                  <a:srgbClr val="94A3B8"/>
+                </a:solidFill>
+              </a:defRPr>
+            </a:pPr>
+            <a:r>
+              <a:t>Cases (millions) vs deaths (thousands) differ by 1,000x. Secondary axis reveals decoupling during 2022 Omicron wave.</a:t>
+            </a:r>
+          </a:p>
+        </p:txBody>
+      </p:sp>
+      <p:sp>
+        <p:nvSpPr>
+          <p:cNvPr id="5" name="Rounded Rectangle 4"/>
+          <p:cNvSpPr/>
           <p:nvPr/>
         </p:nvSpPr>
         <p:spPr>
           <a:xfrm>
-            <a:off x="6400800" y="1280160"/>
-            <a:ext cx="5120640" cy="3139321"/>
+            <a:off x="731520" y="2468880"/>
+            <a:ext cx="10698480" cy="868680"/>
           </a:xfrm>
-          <a:prstGeom prst="rect">
+          <a:prstGeom prst="roundRect">
             <a:avLst/>
           </a:prstGeom>
-          <a:noFill/>
+          <a:solidFill>
+            <a:srgbClr val="1E293B"/>
+          </a:solidFill>
+          <a:ln>
+            <a:solidFill>
+              <a:srgbClr val="3B82F6"/>
+            </a:solidFill>
+          </a:ln>
         </p:spPr>
-        <p:txBody>
-          <a:bodyPr wrap="square">
-            <a:spAutoFit/>
-          </a:bodyPr>
-          <a:lstStyle/>
+        <p:style>
+          <a:lnRef idx="1">
+            <a:schemeClr val="accent1"/>
+          </a:lnRef>
+          <a:fillRef idx="3">
+            <a:schemeClr val="accent1"/>
+          </a:fillRef>
+          <a:effectRef idx="2">
+            <a:schemeClr val="accent1"/>
+          </a:effectRef>
+          <a:fontRef idx="minor">
+            <a:schemeClr val="lt1"/>
+          </a:fontRef>
+        </p:style>
+        <p:txBody>
+          <a:bodyPr rtlCol="0" anchor="ctr"/>
+          <a:lstStyle/>
+          <a:p>
+            <a:pPr algn="ctr">
+              <a:defRPr b="1" sz="1400">
+                <a:solidFill>
+                  <a:srgbClr val="3B82F6"/>
+                </a:solidFill>
+              </a:defRPr>
+            </a:pPr>
+            <a:r>
+              <a:t>Q2. Demographic Age vs Deaths  ➔  [Scatter Plot by Continent]</a:t>
+            </a:r>
+          </a:p>
           <a:p>
             <a:pPr>
-              <a:spcAft>
-                <a:spcPts val="800"/>
-              </a:spcAft>
-              <a:defRPr sz="1800" b="1">
-                <a:solidFill>
-                  <a:srgbClr val="4472C4"/>
-                </a:solidFill>
-                <a:latin typeface="Calibri"/>
+              <a:defRPr sz="1200">
+                <a:solidFill>
+                  <a:srgbClr val="94A3B8"/>
+                </a:solidFill>
               </a:defRPr>
             </a:pPr>
             <a:r>
-              <a:rPr dirty="0"/>
-              <a:t>Five Analytical Questions</a:t>
+              <a:t>Shows positive correlation while spotlighting outliers like Japan (high age, low deaths) and Peru.</a:t>
+            </a:r>
+          </a:p>
+        </p:txBody>
+      </p:sp>
+      <p:sp>
+        <p:nvSpPr>
+          <p:cNvPr id="6" name="Rounded Rectangle 5"/>
+          <p:cNvSpPr/>
+          <p:nvPr/>
+        </p:nvSpPr>
+        <p:spPr>
+          <a:xfrm>
+            <a:off x="731520" y="3474720"/>
+            <a:ext cx="10698480" cy="868680"/>
+          </a:xfrm>
+          <a:prstGeom prst="roundRect">
+            <a:avLst/>
+          </a:prstGeom>
+          <a:solidFill>
+            <a:srgbClr val="1E293B"/>
+          </a:solidFill>
+          <a:ln>
+            <a:solidFill>
+              <a:srgbClr val="3B82F6"/>
+            </a:solidFill>
+          </a:ln>
+        </p:spPr>
+        <p:style>
+          <a:lnRef idx="1">
+            <a:schemeClr val="accent1"/>
+          </a:lnRef>
+          <a:fillRef idx="3">
+            <a:schemeClr val="accent1"/>
+          </a:fillRef>
+          <a:effectRef idx="2">
+            <a:schemeClr val="accent1"/>
+          </a:effectRef>
+          <a:fontRef idx="minor">
+            <a:schemeClr val="lt1"/>
+          </a:fontRef>
+        </p:style>
+        <p:txBody>
+          <a:bodyPr rtlCol="0" anchor="ctr"/>
+          <a:lstStyle/>
+          <a:p>
+            <a:pPr algn="ctr">
+              <a:defRPr b="1" sz="1400">
+                <a:solidFill>
+                  <a:srgbClr val="3B82F6"/>
+                </a:solidFill>
+              </a:defRPr>
+            </a:pPr>
+            <a:r>
+              <a:t>Q3. Continental Spread  ➔  [Box Plot by Continent]</a:t>
             </a:r>
           </a:p>
           <a:p>
             <a:pPr>
-              <a:spcAft>
-                <a:spcPts val="400"/>
-              </a:spcAft>
-              <a:defRPr sz="1300">
-                <a:solidFill>
-                  <a:srgbClr val="C8C8C8"/>
-                </a:solidFill>
-                <a:latin typeface="Calibri"/>
+              <a:defRPr sz="1200">
+                <a:solidFill>
+                  <a:srgbClr val="94A3B8"/>
+                </a:solidFill>
               </a:defRPr>
             </a:pPr>
             <a:r>
-              <a:rPr sz="1600" dirty="0"/>
-              <a:t>Q1: Cases vs. deaths over time — did later waves decouple? → Dual Line Chart</a:t>
+              <a:t>Demonstrates that inter-continental differences dominate over variation inside individual continents.</a:t>
+            </a:r>
+          </a:p>
+        </p:txBody>
+      </p:sp>
+      <p:sp>
+        <p:nvSpPr>
+          <p:cNvPr id="7" name="Rounded Rectangle 6"/>
+          <p:cNvSpPr/>
+          <p:nvPr/>
+        </p:nvSpPr>
+        <p:spPr>
+          <a:xfrm>
+            <a:off x="731520" y="4480560"/>
+            <a:ext cx="10698480" cy="868680"/>
+          </a:xfrm>
+          <a:prstGeom prst="roundRect">
+            <a:avLst/>
+          </a:prstGeom>
+          <a:solidFill>
+            <a:srgbClr val="1E293B"/>
+          </a:solidFill>
+          <a:ln>
+            <a:solidFill>
+              <a:srgbClr val="3B82F6"/>
+            </a:solidFill>
+          </a:ln>
+        </p:spPr>
+        <p:style>
+          <a:lnRef idx="1">
+            <a:schemeClr val="accent1"/>
+          </a:lnRef>
+          <a:fillRef idx="3">
+            <a:schemeClr val="accent1"/>
+          </a:fillRef>
+          <a:effectRef idx="2">
+            <a:schemeClr val="accent1"/>
+          </a:effectRef>
+          <a:fontRef idx="minor">
+            <a:schemeClr val="lt1"/>
+          </a:fontRef>
+        </p:style>
+        <p:txBody>
+          <a:bodyPr rtlCol="0" anchor="ctr"/>
+          <a:lstStyle/>
+          <a:p>
+            <a:pPr algn="ctr">
+              <a:defRPr b="1" sz="1400">
+                <a:solidFill>
+                  <a:srgbClr val="3B82F6"/>
+                </a:solidFill>
+              </a:defRPr>
+            </a:pPr>
+            <a:r>
+              <a:t>Q4. Seasonal Mortality Cycles  ➔  [Year × Month Heatmap]</a:t>
             </a:r>
           </a:p>
           <a:p>
             <a:pPr>
-              <a:spcAft>
-                <a:spcPts val="400"/>
-              </a:spcAft>
-              <a:defRPr sz="1300">
-                <a:solidFill>
-                  <a:srgbClr val="C8C8C8"/>
-                </a:solidFill>
-                <a:latin typeface="Calibri"/>
+              <a:defRPr sz="1200">
+                <a:solidFill>
+                  <a:srgbClr val="94A3B8"/>
+                </a:solidFill>
               </a:defRPr>
             </a:pPr>
             <a:r>
-              <a:rPr sz="1600" dirty="0"/>
-              <a:t>Q2: Does higher median age always mean more deaths? → Scatter Plot (by continent)</a:t>
+              <a:t>Recurring dark bands in Dec, Jan, and Feb expose respiratory winter surge cycles across consecutive years.</a:t>
+            </a:r>
+          </a:p>
+        </p:txBody>
+      </p:sp>
+      <p:sp>
+        <p:nvSpPr>
+          <p:cNvPr id="8" name="Rounded Rectangle 7"/>
+          <p:cNvSpPr/>
+          <p:nvPr/>
+        </p:nvSpPr>
+        <p:spPr>
+          <a:xfrm>
+            <a:off x="731520" y="5486400"/>
+            <a:ext cx="10698480" cy="868680"/>
+          </a:xfrm>
+          <a:prstGeom prst="roundRect">
+            <a:avLst/>
+          </a:prstGeom>
+          <a:solidFill>
+            <a:srgbClr val="1E293B"/>
+          </a:solidFill>
+          <a:ln>
+            <a:solidFill>
+              <a:srgbClr val="3B82F6"/>
+            </a:solidFill>
+          </a:ln>
+        </p:spPr>
+        <p:style>
+          <a:lnRef idx="1">
+            <a:schemeClr val="accent1"/>
+          </a:lnRef>
+          <a:fillRef idx="3">
+            <a:schemeClr val="accent1"/>
+          </a:fillRef>
+          <a:effectRef idx="2">
+            <a:schemeClr val="accent1"/>
+          </a:effectRef>
+          <a:fontRef idx="minor">
+            <a:schemeClr val="lt1"/>
+          </a:fontRef>
+        </p:style>
+        <p:txBody>
+          <a:bodyPr rtlCol="0" anchor="ctr"/>
+          <a:lstStyle/>
+          <a:p>
+            <a:pPr algn="ctr">
+              <a:defRPr b="1" sz="1400">
+                <a:solidFill>
+                  <a:srgbClr val="3B82F6"/>
+                </a:solidFill>
+              </a:defRPr>
+            </a:pPr>
+            <a:r>
+              <a:t>Q5. Global Vaccine Equity  ➔  [Frequency Histogram]</a:t>
             </a:r>
           </a:p>
           <a:p>
             <a:pPr>
-              <a:spcAft>
-                <a:spcPts val="400"/>
-              </a:spcAft>
-              <a:defRPr sz="1300">
-                <a:solidFill>
-                  <a:srgbClr val="C8C8C8"/>
-                </a:solidFill>
-                <a:latin typeface="Calibri"/>
+              <a:defRPr sz="1200">
+                <a:solidFill>
+                  <a:srgbClr val="94A3B8"/>
+                </a:solidFill>
               </a:defRPr>
             </a:pPr>
             <a:r>
-              <a:rPr sz="1600" dirty="0"/>
-              <a:t>Q3: Death-rate variation between vs. within continents → Box Plot</a:t>
-            </a:r>
-          </a:p>
-          <a:p>
-            <a:pPr>
-              <a:spcAft>
-                <a:spcPts val="400"/>
-              </a:spcAft>
-              <a:defRPr sz="1300">
-                <a:solidFill>
-                  <a:srgbClr val="C8C8C8"/>
-                </a:solidFill>
-                <a:latin typeface="Calibri"/>
-              </a:defRPr>
-            </a:pPr>
-            <a:r>
-              <a:rPr sz="1600" dirty="0"/>
-              <a:t>Q4: Seasonal mortality patterns? → Heatmap (year × month)</a:t>
-            </a:r>
-          </a:p>
-          <a:p>
-            <a:pPr>
-              <a:spcAft>
-                <a:spcPts val="400"/>
-              </a:spcAft>
-              <a:defRPr sz="1300">
-                <a:solidFill>
-                  <a:srgbClr val="C8C8C8"/>
-                </a:solidFill>
-                <a:latin typeface="Calibri"/>
-              </a:defRPr>
-            </a:pPr>
-            <a:r>
-              <a:rPr sz="1600" dirty="0"/>
-              <a:t>Q5: Vaccination coverage — one cluster or two? → Histogram</a:t>
+              <a:t>Reveals a stark bimodal distribution (&lt;30% vs &gt;75%) that a single global average completely conceals.</a:t>
             </a:r>
           </a:p>
         </p:txBody>
@@ -3878,82 +3785,31 @@
 </file>
 
 <file path=ppt/slides/slide3.xml><?xml version="1.0" encoding="utf-8"?>
-<p:sld xmlns:a="http://schemas.openxmlformats.org/drawingml/2006/main" xmlns:r="http://schemas.openxmlformats.org/officeDocument/2006/relationships" xmlns:p="http://schemas.openxmlformats.org/presentationml/2006/main">
+<p:sld xmlns:a="http://schemas.openxmlformats.org/drawingml/2006/main" xmlns:p="http://schemas.openxmlformats.org/presentationml/2006/main" xmlns:r="http://schemas.openxmlformats.org/officeDocument/2006/relationships">
   <p:cSld>
-    <p:bg>
-      <p:bgPr>
-        <a:solidFill>
-          <a:srgbClr val="0D1B2A"/>
-        </a:solidFill>
-        <a:effectLst/>
-      </p:bgPr>
-    </p:bg>
     <p:spTree>
       <p:nvGrpSpPr>
         <p:cNvPr id="1" name=""/>
         <p:cNvGrpSpPr/>
         <p:nvPr/>
       </p:nvGrpSpPr>
-      <p:grpSpPr>
-        <a:xfrm>
-          <a:off x="0" y="0"/>
-          <a:ext cx="0" cy="0"/>
-          <a:chOff x="0" y="0"/>
-          <a:chExt cx="0" cy="0"/>
-        </a:xfrm>
-      </p:grpSpPr>
-      <p:sp>
-        <p:nvSpPr>
-          <p:cNvPr id="2" name="TextBox 1"/>
-          <p:cNvSpPr txBox="1"/>
+      <p:grpSpPr/>
+      <p:sp>
+        <p:nvSpPr>
+          <p:cNvPr id="2" name="Rectangle 1"/>
+          <p:cNvSpPr/>
           <p:nvPr/>
         </p:nvSpPr>
         <p:spPr>
           <a:xfrm>
-            <a:off x="457200" y="274320"/>
-            <a:ext cx="10972800" cy="640080"/>
+            <a:off x="0" y="0"/>
+            <a:ext cx="12191695" cy="6858000"/>
           </a:xfrm>
           <a:prstGeom prst="rect">
             <a:avLst/>
           </a:prstGeom>
-          <a:noFill/>
-        </p:spPr>
-        <p:txBody>
-          <a:bodyPr wrap="square">
-            <a:spAutoFit/>
-          </a:bodyPr>
-          <a:lstStyle/>
-          <a:p>
-            <a:pPr algn="l">
-              <a:defRPr sz="3000" b="1">
-                <a:solidFill>
-                  <a:srgbClr val="FFFFFF"/>
-                </a:solidFill>
-                <a:latin typeface="Calibri"/>
-              </a:defRPr>
-            </a:pPr>
-            <a:r>
-              <a:t>Key Findings &amp; Recommendations</a:t>
-            </a:r>
-          </a:p>
-        </p:txBody>
-      </p:sp>
-      <p:sp>
-        <p:nvSpPr>
-          <p:cNvPr id="3" name="Rounded Rectangle 2"/>
-          <p:cNvSpPr/>
-          <p:nvPr/>
-        </p:nvSpPr>
-        <p:spPr>
-          <a:xfrm>
-            <a:off x="457200" y="1097280"/>
-            <a:ext cx="5943600" cy="5303520"/>
-          </a:xfrm>
-          <a:prstGeom prst="roundRect">
-            <a:avLst/>
-          </a:prstGeom>
           <a:solidFill>
-            <a:srgbClr val="1B3A5C"/>
+            <a:srgbClr val="0F172A"/>
           </a:solidFill>
           <a:ln>
             <a:noFill/>
@@ -3978,20 +3834,19 @@
           <a:lstStyle/>
           <a:p>
             <a:pPr algn="ctr"/>
-            <a:endParaRPr/>
-          </a:p>
-        </p:txBody>
-      </p:sp>
-      <p:sp>
-        <p:nvSpPr>
-          <p:cNvPr id="4" name="TextBox 3"/>
+          </a:p>
+        </p:txBody>
+      </p:sp>
+      <p:sp>
+        <p:nvSpPr>
+          <p:cNvPr id="3" name="TextBox 2"/>
           <p:cNvSpPr txBox="1"/>
           <p:nvPr/>
         </p:nvSpPr>
         <p:spPr>
           <a:xfrm>
-            <a:off x="640080" y="1280160"/>
-            <a:ext cx="5577840" cy="4937760"/>
+            <a:off x="731520" y="457200"/>
+            <a:ext cx="10698480" cy="731520"/>
           </a:xfrm>
           <a:prstGeom prst="rect">
             <a:avLst/>
@@ -3999,127 +3854,93 @@
           <a:noFill/>
         </p:spPr>
         <p:txBody>
-          <a:bodyPr wrap="square">
+          <a:bodyPr wrap="none">
             <a:spAutoFit/>
           </a:bodyPr>
           <a:lstStyle/>
           <a:p>
             <a:pPr>
-              <a:spcAft>
-                <a:spcPts val="800"/>
-              </a:spcAft>
-              <a:defRPr sz="1800" b="1">
-                <a:solidFill>
-                  <a:srgbClr val="FFC107"/>
-                </a:solidFill>
-                <a:latin typeface="Calibri"/>
+              <a:defRPr sz="2800" b="1">
+                <a:solidFill>
+                  <a:srgbClr val="F1F5F9"/>
+                </a:solidFill>
               </a:defRPr>
             </a:pPr>
             <a:r>
-              <a:t>Five Major Findings</a:t>
-            </a:r>
-          </a:p>
-          <a:p>
-            <a:pPr>
-              <a:spcAft>
-                <a:spcPts val="400"/>
-              </a:spcAft>
-              <a:defRPr sz="1400">
-                <a:solidFill>
-                  <a:srgbClr val="C8C8C8"/>
-                </a:solidFill>
-                <a:latin typeface="Calibri"/>
-              </a:defRPr>
-            </a:pPr>
-            <a:r>
-              <a:t>1. Later waves had record cases but far fewer deaths — vaccines work.</a:t>
-            </a:r>
-          </a:p>
-          <a:p>
-            <a:pPr>
-              <a:spcAft>
-                <a:spcPts val="400"/>
-              </a:spcAft>
-              <a:defRPr sz="1400">
-                <a:solidFill>
-                  <a:srgbClr val="C8C8C8"/>
-                </a:solidFill>
-                <a:latin typeface="Calibri"/>
-              </a:defRPr>
-            </a:pPr>
-            <a:r>
-              <a:t>2. Older countries had more deaths per million, but Japan &amp; others broke the pattern — policy matters.</a:t>
-            </a:r>
-          </a:p>
-          <a:p>
-            <a:pPr>
-              <a:spcAft>
-                <a:spcPts val="400"/>
-              </a:spcAft>
-              <a:defRPr sz="1400">
-                <a:solidFill>
-                  <a:srgbClr val="C8C8C8"/>
-                </a:solidFill>
-                <a:latin typeface="Calibri"/>
-              </a:defRPr>
-            </a:pPr>
-            <a:r>
-              <a:t>3. Between-continent death-rate variation exceeds within-continent variation.</a:t>
-            </a:r>
-          </a:p>
-          <a:p>
-            <a:pPr>
-              <a:spcAft>
-                <a:spcPts val="400"/>
-              </a:spcAft>
-              <a:defRPr sz="1400">
-                <a:solidFill>
-                  <a:srgbClr val="C8C8C8"/>
-                </a:solidFill>
-                <a:latin typeface="Calibri"/>
-              </a:defRPr>
-            </a:pPr>
-            <a:r>
-              <a:t>4. Northern Hemisphere winter months are consistently deadlier — seasonal pattern confirmed.</a:t>
-            </a:r>
-          </a:p>
-          <a:p>
-            <a:pPr>
-              <a:spcAft>
-                <a:spcPts val="400"/>
-              </a:spcAft>
-              <a:defRPr sz="1400">
-                <a:solidFill>
-                  <a:srgbClr val="C8C8C8"/>
-                </a:solidFill>
-                <a:latin typeface="Calibri"/>
-              </a:defRPr>
-            </a:pPr>
-            <a:r>
-              <a:t>5. Global vaccination coverage is bimodal — two distinct groups of countries exist.</a:t>
-            </a:r>
-          </a:p>
-        </p:txBody>
-      </p:sp>
-      <p:sp>
-        <p:nvSpPr>
-          <p:cNvPr id="5" name="Rounded Rectangle 4"/>
+              <a:t>Live Dashboard Showcase &amp; Visualizations</a:t>
+            </a:r>
+          </a:p>
+        </p:txBody>
+      </p:sp>
+      <p:pic>
+        <p:nvPicPr>
+          <p:cNvPr id="4" name="Picture 3" descr="screenshot_1_overview_kpis.png"/>
+          <p:cNvPicPr>
+            <a:picLocks noChangeAspect="1"/>
+          </p:cNvPicPr>
+          <p:nvPr/>
+        </p:nvPicPr>
+        <p:blipFill>
+          <a:blip r:embed="rId2"/>
+          <a:stretch>
+            <a:fillRect/>
+          </a:stretch>
+        </p:blipFill>
+        <p:spPr>
+          <a:xfrm>
+            <a:off x="731520" y="1371600"/>
+            <a:ext cx="5212080" cy="2962335"/>
+          </a:xfrm>
+          <a:prstGeom prst="rect">
+            <a:avLst/>
+          </a:prstGeom>
+        </p:spPr>
+      </p:pic>
+      <p:pic>
+        <p:nvPicPr>
+          <p:cNvPr id="5" name="Picture 4" descr="screenshot_2_time_series_trends.png"/>
+          <p:cNvPicPr>
+            <a:picLocks noChangeAspect="1"/>
+          </p:cNvPicPr>
+          <p:nvPr/>
+        </p:nvPicPr>
+        <p:blipFill>
+          <a:blip r:embed="rId3"/>
+          <a:stretch>
+            <a:fillRect/>
+          </a:stretch>
+        </p:blipFill>
+        <p:spPr>
+          <a:xfrm>
+            <a:off x="6217920" y="1371600"/>
+            <a:ext cx="5212080" cy="3003054"/>
+          </a:xfrm>
+          <a:prstGeom prst="rect">
+            <a:avLst/>
+          </a:prstGeom>
+        </p:spPr>
+      </p:pic>
+      <p:sp>
+        <p:nvSpPr>
+          <p:cNvPr id="6" name="Rectangle 5"/>
           <p:cNvSpPr/>
           <p:nvPr/>
         </p:nvSpPr>
         <p:spPr>
           <a:xfrm>
-            <a:off x="6583680" y="1109345"/>
-            <a:ext cx="5029200" cy="5303520"/>
+            <a:off x="731520" y="4937760"/>
+            <a:ext cx="10698480" cy="1280160"/>
           </a:xfrm>
-          <a:prstGeom prst="roundRect">
+          <a:prstGeom prst="rect">
             <a:avLst/>
           </a:prstGeom>
           <a:solidFill>
-            <a:srgbClr val="1B3A5C"/>
+            <a:srgbClr val="1E293B"/>
           </a:solidFill>
           <a:ln>
-            <a:noFill/>
+            <a:solidFill>
+              <a:srgbClr val="334155"/>
+            </a:solidFill>
           </a:ln>
         </p:spPr>
         <p:style>
@@ -4140,179 +3961,27 @@
           <a:bodyPr rtlCol="0" anchor="ctr"/>
           <a:lstStyle/>
           <a:p>
-            <a:pPr algn="ctr"/>
-            <a:endParaRPr/>
-          </a:p>
-        </p:txBody>
-      </p:sp>
-      <p:sp>
-        <p:nvSpPr>
-          <p:cNvPr id="6" name="TextBox 5"/>
-          <p:cNvSpPr txBox="1"/>
-          <p:nvPr/>
-        </p:nvSpPr>
-        <p:spPr>
-          <a:xfrm>
-            <a:off x="6766560" y="1463040"/>
-            <a:ext cx="4663440" cy="2298065"/>
-          </a:xfrm>
-          <a:prstGeom prst="rect">
-            <a:avLst/>
-          </a:prstGeom>
-          <a:noFill/>
-        </p:spPr>
-        <p:txBody>
-          <a:bodyPr wrap="square">
-            <a:spAutoFit/>
-          </a:bodyPr>
-          <a:lstStyle/>
+            <a:pPr algn="ctr">
+              <a:defRPr sz="1400">
+                <a:solidFill>
+                  <a:srgbClr val="F1F5F9"/>
+                </a:solidFill>
+              </a:defRPr>
+            </a:pPr>
+            <a:r>
+              <a:t>Interactive Features: Real-time KPI cards, country multiselect, date window slider, and dual-axis longitudinal trend comparisons.</a:t>
+            </a:r>
+          </a:p>
           <a:p>
             <a:pPr>
-              <a:spcAft>
-                <a:spcPts val="800"/>
-              </a:spcAft>
-              <a:defRPr sz="1800" b="1">
-                <a:solidFill>
-                  <a:srgbClr val="27AE60"/>
-                </a:solidFill>
-                <a:latin typeface="Calibri"/>
+              <a:defRPr sz="1300" b="1">
+                <a:solidFill>
+                  <a:srgbClr val="22C55E"/>
+                </a:solidFill>
               </a:defRPr>
             </a:pPr>
             <a:r>
-              <a:rPr dirty="0"/>
-              <a:t>Three Actionable Recommendations</a:t>
-            </a:r>
-          </a:p>
-          <a:p>
-            <a:pPr>
-              <a:spcAft>
-                <a:spcPts val="400"/>
-              </a:spcAft>
-              <a:defRPr sz="1400">
-                <a:solidFill>
-                  <a:srgbClr val="C8C8C8"/>
-                </a:solidFill>
-                <a:latin typeface="Calibri"/>
-              </a:defRPr>
-            </a:pPr>
-            <a:r>
-              <a:rPr sz="1600" dirty="0"/>
-              <a:t>1. Close the vaccination gap — fund COVAX-style programs and regional manufacturing.</a:t>
-            </a:r>
-          </a:p>
-          <a:p>
-            <a:pPr>
-              <a:spcAft>
-                <a:spcPts val="400"/>
-              </a:spcAft>
-              <a:defRPr sz="1400">
-                <a:solidFill>
-                  <a:srgbClr val="C8C8C8"/>
-                </a:solidFill>
-                <a:latin typeface="Calibri"/>
-              </a:defRPr>
-            </a:pPr>
-            <a:r>
-              <a:rPr sz="1600" dirty="0"/>
-              <a:t>2. Prepare healthcare seasonally — deploy boosters pre-winter, surge hospital capacity in peak months.</a:t>
-            </a:r>
-          </a:p>
-          <a:p>
-            <a:pPr>
-              <a:spcAft>
-                <a:spcPts val="400"/>
-              </a:spcAft>
-              <a:defRPr sz="1400">
-                <a:solidFill>
-                  <a:srgbClr val="C8C8C8"/>
-                </a:solidFill>
-                <a:latin typeface="Calibri"/>
-              </a:defRPr>
-            </a:pPr>
-            <a:r>
-              <a:rPr sz="1600" dirty="0"/>
-              <a:t>3. Standardize global data reporting — mandatory minimum indicators for faster, evidence-based response.</a:t>
-            </a:r>
-          </a:p>
-        </p:txBody>
-      </p:sp>
-      <p:sp>
-        <p:nvSpPr>
-          <p:cNvPr id="7" name="Rounded Rectangle 6"/>
-          <p:cNvSpPr/>
-          <p:nvPr/>
-        </p:nvSpPr>
-        <p:spPr>
-          <a:xfrm>
-            <a:off x="6583680" y="4572000"/>
-            <a:ext cx="5029200" cy="1828800"/>
-          </a:xfrm>
-          <a:prstGeom prst="roundRect">
-            <a:avLst/>
-          </a:prstGeom>
-          <a:solidFill>
-            <a:srgbClr val="3D1E1E"/>
-          </a:solidFill>
-          <a:ln w="12700">
-            <a:solidFill>
-              <a:srgbClr val="E74C3C"/>
-            </a:solidFill>
-          </a:ln>
-        </p:spPr>
-        <p:style>
-          <a:lnRef idx="1">
-            <a:schemeClr val="accent1"/>
-          </a:lnRef>
-          <a:fillRef idx="3">
-            <a:schemeClr val="accent1"/>
-          </a:fillRef>
-          <a:effectRef idx="2">
-            <a:schemeClr val="accent1"/>
-          </a:effectRef>
-          <a:fontRef idx="minor">
-            <a:schemeClr val="lt1"/>
-          </a:fontRef>
-        </p:style>
-        <p:txBody>
-          <a:bodyPr wrap="square" rtlCol="0" anchor="ctr"/>
-          <a:lstStyle/>
-          <a:p>
-            <a:pPr algn="ctr">
-              <a:defRPr sz="1400" b="1">
-                <a:solidFill>
-                  <a:srgbClr val="E74C3C"/>
-                </a:solidFill>
-                <a:latin typeface="Calibri"/>
-              </a:defRPr>
-            </a:pPr>
-            <a:r>
-              <a:t>Wrong Viz Challenge (Q5)</a:t>
-            </a:r>
-          </a:p>
-          <a:p>
-            <a:pPr>
-              <a:defRPr sz="1200">
-                <a:solidFill>
-                  <a:srgbClr val="27AE60"/>
-                </a:solidFill>
-                <a:latin typeface="Calibri"/>
-              </a:defRPr>
-            </a:pPr>
-            <a:r>
-              <a:t>✓ Histogram → shows bimodal distribution</a:t>
-            </a:r>
-          </a:p>
-          <a:p>
-            <a:pPr>
-              <a:defRPr sz="1200">
-                <a:solidFill>
-                  <a:srgbClr val="E74C3C"/>
-                </a:solidFill>
-                <a:latin typeface="Calibri"/>
-              </a:defRPr>
-            </a:pPr>
-            <a:r>
-              <a:t>✗ Pie Chart → hides distribution shape, masks the two-group reality</a:t>
+              <a:t>Live App Link: https://covid19-global-data-explorer-lqpxjhstcgzwc7gxhnshtd.streamlit.app/</a:t>
             </a:r>
           </a:p>
         </p:txBody>
@@ -4326,82 +3995,31 @@
 </file>
 
 <file path=ppt/slides/slide4.xml><?xml version="1.0" encoding="utf-8"?>
-<p:sld xmlns:a="http://schemas.openxmlformats.org/drawingml/2006/main" xmlns:r="http://schemas.openxmlformats.org/officeDocument/2006/relationships" xmlns:p="http://schemas.openxmlformats.org/presentationml/2006/main">
+<p:sld xmlns:a="http://schemas.openxmlformats.org/drawingml/2006/main" xmlns:p="http://schemas.openxmlformats.org/presentationml/2006/main" xmlns:r="http://schemas.openxmlformats.org/officeDocument/2006/relationships">
   <p:cSld>
-    <p:bg>
-      <p:bgPr>
-        <a:solidFill>
-          <a:srgbClr val="0D1B2A"/>
-        </a:solidFill>
-        <a:effectLst/>
-      </p:bgPr>
-    </p:bg>
     <p:spTree>
       <p:nvGrpSpPr>
         <p:cNvPr id="1" name=""/>
         <p:cNvGrpSpPr/>
         <p:nvPr/>
       </p:nvGrpSpPr>
-      <p:grpSpPr>
-        <a:xfrm>
-          <a:off x="0" y="0"/>
-          <a:ext cx="0" cy="0"/>
-          <a:chOff x="0" y="0"/>
-          <a:chExt cx="0" cy="0"/>
-        </a:xfrm>
-      </p:grpSpPr>
-      <p:sp>
-        <p:nvSpPr>
-          <p:cNvPr id="2" name="TextBox 1"/>
-          <p:cNvSpPr txBox="1"/>
+      <p:grpSpPr/>
+      <p:sp>
+        <p:nvSpPr>
+          <p:cNvPr id="2" name="Rectangle 1"/>
+          <p:cNvSpPr/>
           <p:nvPr/>
         </p:nvSpPr>
         <p:spPr>
           <a:xfrm>
-            <a:off x="457200" y="274320"/>
-            <a:ext cx="10972800" cy="640080"/>
+            <a:off x="0" y="0"/>
+            <a:ext cx="12191695" cy="6858000"/>
           </a:xfrm>
           <a:prstGeom prst="rect">
             <a:avLst/>
           </a:prstGeom>
-          <a:noFill/>
-        </p:spPr>
-        <p:txBody>
-          <a:bodyPr wrap="square">
-            <a:spAutoFit/>
-          </a:bodyPr>
-          <a:lstStyle/>
-          <a:p>
-            <a:pPr algn="l">
-              <a:defRPr sz="3000" b="1">
-                <a:solidFill>
-                  <a:srgbClr val="FFFFFF"/>
-                </a:solidFill>
-                <a:latin typeface="Calibri"/>
-              </a:defRPr>
-            </a:pPr>
-            <a:r>
-              <a:t>AI Critique, Data Story &amp; Conclusion</a:t>
-            </a:r>
-          </a:p>
-        </p:txBody>
-      </p:sp>
-      <p:sp>
-        <p:nvSpPr>
-          <p:cNvPr id="3" name="Rounded Rectangle 2"/>
-          <p:cNvSpPr/>
-          <p:nvPr/>
-        </p:nvSpPr>
-        <p:spPr>
-          <a:xfrm>
-            <a:off x="457200" y="1097280"/>
-            <a:ext cx="5486400" cy="2743200"/>
-          </a:xfrm>
-          <a:prstGeom prst="roundRect">
-            <a:avLst/>
-          </a:prstGeom>
           <a:solidFill>
-            <a:srgbClr val="1B3A5C"/>
+            <a:srgbClr val="0F172A"/>
           </a:solidFill>
           <a:ln>
             <a:noFill/>
@@ -4426,20 +4044,19 @@
           <a:lstStyle/>
           <a:p>
             <a:pPr algn="ctr"/>
-            <a:endParaRPr/>
-          </a:p>
-        </p:txBody>
-      </p:sp>
-      <p:sp>
-        <p:nvSpPr>
-          <p:cNvPr id="4" name="TextBox 3"/>
+          </a:p>
+        </p:txBody>
+      </p:sp>
+      <p:sp>
+        <p:nvSpPr>
+          <p:cNvPr id="3" name="TextBox 2"/>
           <p:cNvSpPr txBox="1"/>
           <p:nvPr/>
         </p:nvSpPr>
         <p:spPr>
           <a:xfrm>
-            <a:off x="640080" y="1280160"/>
-            <a:ext cx="5120640" cy="2377440"/>
+            <a:off x="731520" y="457200"/>
+            <a:ext cx="10698480" cy="731520"/>
           </a:xfrm>
           <a:prstGeom prst="rect">
             <a:avLst/>
@@ -4447,108 +4064,287 @@
           <a:noFill/>
         </p:spPr>
         <p:txBody>
-          <a:bodyPr wrap="square">
+          <a:bodyPr wrap="none">
             <a:spAutoFit/>
           </a:bodyPr>
           <a:lstStyle/>
           <a:p>
             <a:pPr>
-              <a:spcAft>
-                <a:spcPts val="800"/>
-              </a:spcAft>
-              <a:defRPr sz="1600" b="1">
-                <a:solidFill>
-                  <a:srgbClr val="4472C4"/>
-                </a:solidFill>
-                <a:latin typeface="Calibri"/>
+              <a:defRPr sz="2800" b="1">
+                <a:solidFill>
+                  <a:srgbClr val="F1F5F9"/>
+                </a:solidFill>
               </a:defRPr>
             </a:pPr>
             <a:r>
-              <a:t>AI Critique of Q1 Visualization</a:t>
-            </a:r>
-          </a:p>
-          <a:p>
-            <a:pPr>
-              <a:spcAft>
-                <a:spcPts val="400"/>
-              </a:spcAft>
-              <a:defRPr sz="1300">
-                <a:solidFill>
-                  <a:srgbClr val="C8C8C8"/>
-                </a:solidFill>
-                <a:latin typeface="Calibri"/>
-              </a:defRPr>
-            </a:pPr>
-            <a:r>
-              <a:t>✓ ACCEPTED — Use dual y-axis (cases vs. deaths differ by magnitude)</a:t>
-            </a:r>
-          </a:p>
-          <a:p>
-            <a:pPr>
-              <a:spcAft>
-                <a:spcPts val="400"/>
-              </a:spcAft>
-              <a:defRPr sz="1300">
-                <a:solidFill>
-                  <a:srgbClr val="C8C8C8"/>
-                </a:solidFill>
-                <a:latin typeface="Calibri"/>
-              </a:defRPr>
-            </a:pPr>
-            <a:r>
-              <a:t>✓ ACCEPTED — Add event annotations (vaccine rollout, Omicron wave)</a:t>
-            </a:r>
-          </a:p>
-          <a:p>
-            <a:pPr>
-              <a:spcAft>
-                <a:spcPts val="400"/>
-              </a:spcAft>
-              <a:defRPr sz="1300">
-                <a:solidFill>
-                  <a:srgbClr val="C8C8C8"/>
-                </a:solidFill>
-                <a:latin typeface="Calibri"/>
-              </a:defRPr>
-            </a:pPr>
-            <a:r>
-              <a:t>✗ REJECTED — Log scale (distorts perceived severity for our audience)</a:t>
-            </a:r>
-          </a:p>
-          <a:p>
-            <a:pPr>
-              <a:spcAft>
-                <a:spcPts val="400"/>
-              </a:spcAft>
-              <a:defRPr sz="1300">
-                <a:solidFill>
-                  <a:srgbClr val="C8C8C8"/>
-                </a:solidFill>
-                <a:latin typeface="Calibri"/>
-              </a:defRPr>
-            </a:pPr>
-            <a:r>
-              <a:t>✓ ACCEPTED — Clarify legend labels with '(7-day smoothed)'</a:t>
-            </a:r>
-          </a:p>
-        </p:txBody>
-      </p:sp>
-      <p:sp>
-        <p:nvSpPr>
-          <p:cNvPr id="5" name="Rounded Rectangle 4"/>
+              <a:t>Five Major Findings &amp; Three Actionable Recommendations</a:t>
+            </a:r>
+          </a:p>
+        </p:txBody>
+      </p:sp>
+      <p:sp>
+        <p:nvSpPr>
+          <p:cNvPr id="4" name="Rounded Rectangle 3"/>
           <p:cNvSpPr/>
           <p:nvPr/>
         </p:nvSpPr>
         <p:spPr>
           <a:xfrm>
-            <a:off x="6217920" y="1097280"/>
-            <a:ext cx="5486400" cy="2743200"/>
+            <a:off x="731520" y="1371600"/>
+            <a:ext cx="5212080" cy="4846320"/>
           </a:xfrm>
           <a:prstGeom prst="roundRect">
             <a:avLst/>
           </a:prstGeom>
           <a:solidFill>
-            <a:srgbClr val="1B3A5C"/>
+            <a:srgbClr val="1E293B"/>
+          </a:solidFill>
+          <a:ln>
+            <a:solidFill>
+              <a:srgbClr val="3B82F6"/>
+            </a:solidFill>
+          </a:ln>
+        </p:spPr>
+        <p:style>
+          <a:lnRef idx="1">
+            <a:schemeClr val="accent1"/>
+          </a:lnRef>
+          <a:fillRef idx="3">
+            <a:schemeClr val="accent1"/>
+          </a:fillRef>
+          <a:effectRef idx="2">
+            <a:schemeClr val="accent1"/>
+          </a:effectRef>
+          <a:fontRef idx="minor">
+            <a:schemeClr val="lt1"/>
+          </a:fontRef>
+        </p:style>
+        <p:txBody>
+          <a:bodyPr rtlCol="0" anchor="ctr"/>
+          <a:lstStyle/>
+          <a:p>
+            <a:pPr algn="ctr">
+              <a:defRPr b="1" sz="1600">
+                <a:solidFill>
+                  <a:srgbClr val="3B82F6"/>
+                </a:solidFill>
+              </a:defRPr>
+            </a:pPr>
+            <a:r>
+              <a:t>💡 Five Major Findings</a:t>
+            </a:r>
+          </a:p>
+          <a:p>
+            <a:pPr>
+              <a:defRPr sz="1200">
+                <a:solidFill>
+                  <a:srgbClr val="F1F5F9"/>
+                </a:solidFill>
+              </a:defRPr>
+            </a:pPr>
+            <a:r>
+              <a:t>1. Decoupling: Omicron wave produced 4x cases with proportionally far fewer deaths due to vaccines.</a:t>
+            </a:r>
+          </a:p>
+          <a:p>
+            <a:pPr>
+              <a:defRPr sz="1200">
+                <a:solidFill>
+                  <a:srgbClr val="F1F5F9"/>
+                </a:solidFill>
+              </a:defRPr>
+            </a:pPr>
+            <a:r>
+              <a:t>2. Age Sensitivity: Age correlates with deaths, but Japan was an outlier due to rapid masking.</a:t>
+            </a:r>
+          </a:p>
+          <a:p>
+            <a:pPr>
+              <a:defRPr sz="1200">
+                <a:solidFill>
+                  <a:srgbClr val="F1F5F9"/>
+                </a:solidFill>
+              </a:defRPr>
+            </a:pPr>
+            <a:r>
+              <a:t>3. Continental Disparities: Inter-continental variance exceeded internal continental variation.</a:t>
+            </a:r>
+          </a:p>
+          <a:p>
+            <a:pPr>
+              <a:defRPr sz="1200">
+                <a:solidFill>
+                  <a:srgbClr val="F1F5F9"/>
+                </a:solidFill>
+              </a:defRPr>
+            </a:pPr>
+            <a:r>
+              <a:t>4. Winter Seasonality: Recurring mortality surges in Dec–Feb across consecutive years.</a:t>
+            </a:r>
+          </a:p>
+          <a:p>
+            <a:pPr>
+              <a:defRPr sz="1200">
+                <a:solidFill>
+                  <a:srgbClr val="F1F5F9"/>
+                </a:solidFill>
+              </a:defRPr>
+            </a:pPr>
+            <a:r>
+              <a:t>5. Bimodal Vaccination: Countries split into twin clusters (&lt;30% vs &gt;75%), proving extreme inequity.</a:t>
+            </a:r>
+          </a:p>
+        </p:txBody>
+      </p:sp>
+      <p:sp>
+        <p:nvSpPr>
+          <p:cNvPr id="5" name="Rounded Rectangle 4"/>
+          <p:cNvSpPr/>
+          <p:nvPr/>
+        </p:nvSpPr>
+        <p:spPr>
+          <a:xfrm>
+            <a:off x="6217920" y="1371600"/>
+            <a:ext cx="5212080" cy="4846320"/>
+          </a:xfrm>
+          <a:prstGeom prst="roundRect">
+            <a:avLst/>
+          </a:prstGeom>
+          <a:solidFill>
+            <a:srgbClr val="1E293B"/>
+          </a:solidFill>
+          <a:ln>
+            <a:solidFill>
+              <a:srgbClr val="22C55E"/>
+            </a:solidFill>
+          </a:ln>
+        </p:spPr>
+        <p:style>
+          <a:lnRef idx="1">
+            <a:schemeClr val="accent1"/>
+          </a:lnRef>
+          <a:fillRef idx="3">
+            <a:schemeClr val="accent1"/>
+          </a:fillRef>
+          <a:effectRef idx="2">
+            <a:schemeClr val="accent1"/>
+          </a:effectRef>
+          <a:fontRef idx="minor">
+            <a:schemeClr val="lt1"/>
+          </a:fontRef>
+        </p:style>
+        <p:txBody>
+          <a:bodyPr rtlCol="0" anchor="ctr"/>
+          <a:lstStyle/>
+          <a:p>
+            <a:pPr algn="ctr">
+              <a:defRPr b="1" sz="1600">
+                <a:solidFill>
+                  <a:srgbClr val="22C55E"/>
+                </a:solidFill>
+              </a:defRPr>
+            </a:pPr>
+            <a:r>
+              <a:t>🎯 Three Actionable Recommendations</a:t>
+            </a:r>
+          </a:p>
+          <a:p>
+            <a:pPr>
+              <a:defRPr sz="1200">
+                <a:solidFill>
+                  <a:srgbClr val="F1F5F9"/>
+                </a:solidFill>
+              </a:defRPr>
+            </a:pPr>
+            <a:r>
+              <a:t>1. Regional mRNA Hubs: Fund decentralized vaccine manufacturing in Africa &amp; Latin America.</a:t>
+            </a:r>
+          </a:p>
+          <a:p>
+            <a:pPr>
+              <a:defRPr sz="1200">
+                <a:solidFill>
+                  <a:srgbClr val="F1F5F9"/>
+                </a:solidFill>
+              </a:defRPr>
+            </a:pPr>
+            <a:r>
+              <a:t>2. Seasonal Preparedness: Schedule booster campaigns in autumn ahead of winter surges.</a:t>
+            </a:r>
+          </a:p>
+          <a:p>
+            <a:pPr>
+              <a:defRPr sz="1200">
+                <a:solidFill>
+                  <a:srgbClr val="F1F5F9"/>
+                </a:solidFill>
+              </a:defRPr>
+            </a:pPr>
+            <a:r>
+              <a:t>3. Standardized Surveillance: Mandate unified pandemic reporting standards under WHO.</a:t>
+            </a:r>
+          </a:p>
+          <a:p>
+            <a:br/>
+            <a:pPr>
+              <a:defRPr b="1" sz="1400">
+                <a:solidFill>
+                  <a:srgbClr val="F87171"/>
+                </a:solidFill>
+              </a:defRPr>
+            </a:pPr>
+            <a:r>
+              <a:t>⚠️ Wrong Visualization Challenge (Q5):</a:t>
+            </a:r>
+          </a:p>
+          <a:p>
+            <a:pPr>
+              <a:defRPr sz="1200">
+                <a:solidFill>
+                  <a:srgbClr val="94A3B8"/>
+                </a:solidFill>
+              </a:defRPr>
+            </a:pPr>
+            <a:r>
+              <a:t>Correct Histogram exposes bimodal equity split. Misleading Pie Chart discretizes data into equal slices, concealing the valley of unimmunized nations.</a:t>
+            </a:r>
+          </a:p>
+        </p:txBody>
+      </p:sp>
+    </p:spTree>
+  </p:cSld>
+  <p:clrMapOvr>
+    <a:masterClrMapping/>
+  </p:clrMapOvr>
+</p:sld>
+</file>
+
+<file path=ppt/slides/slide5.xml><?xml version="1.0" encoding="utf-8"?>
+<p:sld xmlns:a="http://schemas.openxmlformats.org/drawingml/2006/main" xmlns:p="http://schemas.openxmlformats.org/presentationml/2006/main" xmlns:r="http://schemas.openxmlformats.org/officeDocument/2006/relationships">
+  <p:cSld>
+    <p:spTree>
+      <p:nvGrpSpPr>
+        <p:cNvPr id="1" name=""/>
+        <p:cNvGrpSpPr/>
+        <p:nvPr/>
+      </p:nvGrpSpPr>
+      <p:grpSpPr/>
+      <p:sp>
+        <p:nvSpPr>
+          <p:cNvPr id="2" name="Rectangle 1"/>
+          <p:cNvSpPr/>
+          <p:nvPr/>
+        </p:nvSpPr>
+        <p:spPr>
+          <a:xfrm>
+            <a:off x="0" y="0"/>
+            <a:ext cx="12191695" cy="6858000"/>
+          </a:xfrm>
+          <a:prstGeom prst="rect">
+            <a:avLst/>
+          </a:prstGeom>
+          <a:solidFill>
+            <a:srgbClr val="0F172A"/>
           </a:solidFill>
           <a:ln>
             <a:noFill/>
@@ -4573,20 +4369,19 @@
           <a:lstStyle/>
           <a:p>
             <a:pPr algn="ctr"/>
-            <a:endParaRPr/>
-          </a:p>
-        </p:txBody>
-      </p:sp>
-      <p:sp>
-        <p:nvSpPr>
-          <p:cNvPr id="6" name="TextBox 5"/>
+          </a:p>
+        </p:txBody>
+      </p:sp>
+      <p:sp>
+        <p:nvSpPr>
+          <p:cNvPr id="3" name="TextBox 2"/>
           <p:cNvSpPr txBox="1"/>
           <p:nvPr/>
         </p:nvSpPr>
         <p:spPr>
           <a:xfrm>
-            <a:off x="6400800" y="1280160"/>
-            <a:ext cx="5120640" cy="2377440"/>
+            <a:off x="731520" y="457200"/>
+            <a:ext cx="10698480" cy="731520"/>
           </a:xfrm>
           <a:prstGeom prst="rect">
             <a:avLst/>
@@ -4594,96 +4389,44 @@
           <a:noFill/>
         </p:spPr>
         <p:txBody>
-          <a:bodyPr wrap="square">
+          <a:bodyPr wrap="none">
             <a:spAutoFit/>
           </a:bodyPr>
           <a:lstStyle/>
           <a:p>
             <a:pPr>
-              <a:spcAft>
-                <a:spcPts val="800"/>
-              </a:spcAft>
-              <a:defRPr sz="1600" b="1">
-                <a:solidFill>
-                  <a:srgbClr val="FFC107"/>
-                </a:solidFill>
-                <a:latin typeface="Calibri"/>
+              <a:defRPr sz="2800" b="1">
+                <a:solidFill>
+                  <a:srgbClr val="F1F5F9"/>
+                </a:solidFill>
               </a:defRPr>
             </a:pPr>
             <a:r>
-              <a:t>2-Minute Data Story</a:t>
-            </a:r>
-          </a:p>
-          <a:p>
-            <a:pPr>
-              <a:spcAft>
-                <a:spcPts val="400"/>
-              </a:spcAft>
-              <a:defRPr sz="1300">
-                <a:solidFill>
-                  <a:srgbClr val="C8C8C8"/>
-                </a:solidFill>
-                <a:latin typeface="Calibri"/>
-              </a:defRPr>
-            </a:pPr>
-            <a:r>
-              <a:t>Discovery: Vaccines decoupled cases from deaths; the world split into two vaccination groups; winter months are deadlier.</a:t>
-            </a:r>
-          </a:p>
-          <a:p>
-            <a:pPr>
-              <a:spcAft>
-                <a:spcPts val="400"/>
-              </a:spcAft>
-              <a:defRPr sz="1300">
-                <a:solidFill>
-                  <a:srgbClr val="C8C8C8"/>
-                </a:solidFill>
-                <a:latin typeface="Calibri"/>
-              </a:defRPr>
-            </a:pPr>
-            <a:r>
-              <a:t>Why it matters: Without visualization, these patterns are invisible in 300K+ rows. Policy needs evidence.</a:t>
-            </a:r>
-          </a:p>
-          <a:p>
-            <a:pPr>
-              <a:spcAft>
-                <a:spcPts val="400"/>
-              </a:spcAft>
-              <a:defRPr sz="1300">
-                <a:solidFill>
-                  <a:srgbClr val="C8C8C8"/>
-                </a:solidFill>
-                <a:latin typeface="Calibri"/>
-              </a:defRPr>
-            </a:pPr>
-            <a:r>
-              <a:t>Action: Close the vaccine gap, prepare seasonally, standardize reporting.</a:t>
-            </a:r>
-          </a:p>
-        </p:txBody>
-      </p:sp>
-      <p:sp>
-        <p:nvSpPr>
-          <p:cNvPr id="7" name="Rounded Rectangle 6"/>
+              <a:t>2-Minute Data Story &amp; AI as a Critic</a:t>
+            </a:r>
+          </a:p>
+        </p:txBody>
+      </p:sp>
+      <p:sp>
+        <p:nvSpPr>
+          <p:cNvPr id="4" name="Rounded Rectangle 3"/>
           <p:cNvSpPr/>
           <p:nvPr/>
         </p:nvSpPr>
         <p:spPr>
           <a:xfrm>
-            <a:off x="1828800" y="4389120"/>
-            <a:ext cx="8503920" cy="2011680"/>
+            <a:off x="731520" y="1371600"/>
+            <a:ext cx="10698480" cy="3017520"/>
           </a:xfrm>
           <a:prstGeom prst="roundRect">
             <a:avLst/>
           </a:prstGeom>
           <a:solidFill>
-            <a:srgbClr val="1B3A5C"/>
+            <a:srgbClr val="1E293B"/>
           </a:solidFill>
-          <a:ln w="25400">
+          <a:ln>
             <a:solidFill>
-              <a:srgbClr val="4472C4"/>
+              <a:srgbClr val="A855F7"/>
             </a:solidFill>
           </a:ln>
         </p:spPr>
@@ -4702,45 +4445,156 @@
           </a:fontRef>
         </p:style>
         <p:txBody>
-          <a:bodyPr wrap="square" rtlCol="0" anchor="ctr"/>
+          <a:bodyPr rtlCol="0" anchor="ctr"/>
           <a:lstStyle/>
           <a:p>
             <a:pPr algn="ctr">
-              <a:defRPr sz="3200" b="1">
-                <a:solidFill>
-                  <a:srgbClr val="FFFFFF"/>
-                </a:solidFill>
-                <a:latin typeface="Calibri"/>
+              <a:defRPr b="1" sz="1600">
+                <a:solidFill>
+                  <a:srgbClr val="C084FC"/>
+                </a:solidFill>
               </a:defRPr>
             </a:pPr>
             <a:r>
-              <a:t>Thank You</a:t>
-            </a:r>
-          </a:p>
+              <a:t>🎙️ 2-Minute Data Story Framework:</a:t>
+            </a:r>
+          </a:p>
+          <a:p>
+            <a:pPr>
+              <a:defRPr sz="1300">
+                <a:solidFill>
+                  <a:srgbClr val="F1F5F9"/>
+                </a:solidFill>
+              </a:defRPr>
+            </a:pPr>
+            <a:r>
+              <a:t>1. What did we discover? Pandemic waves decoupled in 2022 (Omicron peak blunted by vaccines); age did not dictate death rates in Japan; and vaccine coverage formed a bimodal divide.</a:t>
+            </a:r>
+          </a:p>
+          <a:p>
+            <a:pPr>
+              <a:defRPr sz="1300">
+                <a:solidFill>
+                  <a:srgbClr val="F1F5F9"/>
+                </a:solidFill>
+              </a:defRPr>
+            </a:pPr>
+            <a:r>
+              <a:t>2. Why does it matter? Tabular spreadsheets hide these realities. Without dual-axis plots and histograms, vaccine effectiveness is unseen and global vaccine inequality is buried under misleading averages.</a:t>
+            </a:r>
+          </a:p>
+          <a:p>
+            <a:pPr>
+              <a:defRPr sz="1300">
+                <a:solidFill>
+                  <a:srgbClr val="F1F5F9"/>
+                </a:solidFill>
+              </a:defRPr>
+            </a:pPr>
+            <a:r>
+              <a:t>3. What action should be taken? Fund regional manufacturing hubs in low-income nations, schedule seasonal autumn booster surges, and mandate standardized real-time surveillance.</a:t>
+            </a:r>
+          </a:p>
+        </p:txBody>
+      </p:sp>
+      <p:sp>
+        <p:nvSpPr>
+          <p:cNvPr id="5" name="Rounded Rectangle 4"/>
+          <p:cNvSpPr/>
+          <p:nvPr/>
+        </p:nvSpPr>
+        <p:spPr>
+          <a:xfrm>
+            <a:off x="731520" y="4572000"/>
+            <a:ext cx="10698480" cy="1645920"/>
+          </a:xfrm>
+          <a:prstGeom prst="roundRect">
+            <a:avLst/>
+          </a:prstGeom>
+          <a:solidFill>
+            <a:srgbClr val="1E293B"/>
+          </a:solidFill>
+          <a:ln>
+            <a:solidFill>
+              <a:srgbClr val="334155"/>
+            </a:solidFill>
+          </a:ln>
+        </p:spPr>
+        <p:style>
+          <a:lnRef idx="1">
+            <a:schemeClr val="accent1"/>
+          </a:lnRef>
+          <a:fillRef idx="3">
+            <a:schemeClr val="accent1"/>
+          </a:fillRef>
+          <a:effectRef idx="2">
+            <a:schemeClr val="accent1"/>
+          </a:effectRef>
+          <a:fontRef idx="minor">
+            <a:schemeClr val="lt1"/>
+          </a:fontRef>
+        </p:style>
+        <p:txBody>
+          <a:bodyPr rtlCol="0" anchor="ctr"/>
+          <a:lstStyle/>
           <a:p>
             <a:pPr algn="ctr">
-              <a:defRPr sz="1400">
-                <a:solidFill>
-                  <a:srgbClr val="C8C8C8"/>
-                </a:solidFill>
-                <a:latin typeface="Calibri"/>
+              <a:defRPr b="1" sz="1400">
+                <a:solidFill>
+                  <a:srgbClr val="3B82F6"/>
+                </a:solidFill>
               </a:defRPr>
             </a:pPr>
             <a:r>
-              <a:t>Group 2: Aashi Kohad • Himanshu Yadav • Nishant Giri • Shreyash Karemore</a:t>
-            </a:r>
-          </a:p>
-          <a:p>
-            <a:pPr algn="ctr">
-              <a:defRPr sz="1800">
-                <a:solidFill>
-                  <a:srgbClr val="4472C4"/>
-                </a:solidFill>
-                <a:latin typeface="Calibri"/>
+              <a:t>🤖 AI as a Critic Evaluation Summary (Q1):</a:t>
+            </a:r>
+          </a:p>
+          <a:p>
+            <a:pPr>
+              <a:defRPr sz="1100">
+                <a:solidFill>
+                  <a:srgbClr val="94A3B8"/>
+                </a:solidFill>
               </a:defRPr>
             </a:pPr>
             <a:r>
-              <a:t>Questions?</a:t>
+              <a:t>• Dual Y-Axis [ACCEPTED]: Solves 1,000x scale gap between daily cases and deaths.</a:t>
+            </a:r>
+          </a:p>
+          <a:p>
+            <a:pPr>
+              <a:defRPr sz="1100">
+                <a:solidFill>
+                  <a:srgbClr val="94A3B8"/>
+                </a:solidFill>
+              </a:defRPr>
+            </a:pPr>
+            <a:r>
+              <a:t>• Milestone Annotations [ACCEPTED]: Adds vital context (vaccine rollout, Omicron surge).</a:t>
+            </a:r>
+          </a:p>
+          <a:p>
+            <a:pPr>
+              <a:defRPr sz="1100">
+                <a:solidFill>
+                  <a:srgbClr val="94A3B8"/>
+                </a:solidFill>
+              </a:defRPr>
+            </a:pPr>
+            <a:r>
+              <a:t>• Logarithmic Scale [REJECTED]: Distorts public health severity and absolute mortality perception.</a:t>
+            </a:r>
+          </a:p>
+          <a:p>
+            <a:pPr>
+              <a:defRPr sz="1100">
+                <a:solidFill>
+                  <a:srgbClr val="94A3B8"/>
+                </a:solidFill>
+              </a:defRPr>
+            </a:pPr>
+            <a:r>
+              <a:t>• 7-Day Smoothed Label [ACCEPTED]: Ensures transparency regarding weekend reporting lags.</a:t>
             </a:r>
           </a:p>
         </p:txBody>

</xml_diff>